<commit_message>
docs: update slides for the CastRole model
Numbers follow main after the n-ary CastRole change: movies_linked.ttl has 11,868 triples and there are 21 queries (5 local, 6 cast-role, 10 federated). The ontology diagram, mapping table and limitations now show CastRole and the plain-string characterName. The reasoning slide credits check_reasoning.py for the counts instead of claiming a Protégé run. Speaker notes updated in English and Vietnamese.
</commit_message>
<xml_diff>
--- a/slides/Group2_Capstone_Slides.pptx
+++ b/slides/Group2_Capstone_Slides.pptx
@@ -126,7 +126,7 @@
   <p:extLst>
     <p:ext uri="{521415D9-36F7-43E2-AB2F-B90AF26B5E84}">
       <p14:sectionLst xmlns:p14="http://schemas.microsoft.com/office/powerpoint/2010/main">
-        <p14:section name="Introduction" id="{9a946808-7cee-76e8-7aae-bdffbcf7f435}">
+        <p14:section name="Introduction" id="{8a125597-65d1-5ae3-d38c-dd0b973f7980}">
           <p14:sldIdLst>
             <p14:sldId id="256"/>
             <p14:sldId id="257"/>
@@ -134,7 +134,7 @@
             <p14:sldId id="259"/>
           </p14:sldIdLst>
         </p14:section>
-        <p14:section name="Ontology and reasoning" id="{94b1c24c-673f-9ced-d472-981066a195c7}">
+        <p14:section name="Ontology and reasoning" id="{7c06a335-5252-7b87-a9a9-acd069352113}">
           <p14:sldIdLst>
             <p14:sldId id="260"/>
             <p14:sldId id="261"/>
@@ -143,7 +143,7 @@
             <p14:sldId id="264"/>
           </p14:sldIdLst>
         </p14:section>
-        <p14:section name="Data and linking" id="{05f72673-3b6d-d55c-8c66-c8c6144efc5b}">
+        <p14:section name="Data and linking" id="{36858b68-19b0-3d76-42ca-7375615db1f0}">
           <p14:sldIdLst>
             <p14:sldId id="265"/>
             <p14:sldId id="266"/>
@@ -153,14 +153,14 @@
             <p14:sldId id="270"/>
           </p14:sldIdLst>
         </p14:section>
-        <p14:section name="Querying and demo" id="{eee05197-04ee-117d-0e46-1713e1289f2f}">
+        <p14:section name="Querying and demo" id="{40784784-6862-0d82-98ab-67196873e818}">
           <p14:sldIdLst>
             <p14:sldId id="271"/>
             <p14:sldId id="272"/>
             <p14:sldId id="273"/>
           </p14:sldIdLst>
         </p14:section>
-        <p14:section name="Wrap-up" id="{b1297c88-8c32-360b-5a31-890e7e0519dc}">
+        <p14:section name="Wrap-up" id="{5cdde5df-593e-a270-71ff-30da253f5dad}">
           <p14:sldIdLst>
             <p14:sldId id="274"/>
             <p14:sldId id="275"/>
@@ -1142,9 +1142,9 @@
               <a:rPr lang="en-US" dirty="0"/>
               <a:t>Đức · ~40 s
 ENGLISH
-This table shows how each CSV column maps to RDF. The id becomes the movie's URI, typed as schema:Movie. The title goes to Dublin Core, director and cast to the DBpedia ontology, and names to FOAF. Genre, studio and country use our own terms. One design choice is worth pointing out: the URIs reuse the TMDB ids. They stay the same every time we rerun the pipeline, and they also turn out to be the key for linking, as you'll see next.
+This table shows how each CSV column maps to RDF. The id becomes the movie's URI, typed as schema:Movie. The title goes to Dublin Core, director and cast to the DBpedia ontology, and names to FOAF. Genre, studio and country use our own terms. For the cast we keep the simple starring link, and we also create a CastRole for each actor in each movie, with the character name and billing order. One design choice is worth pointing out: the URIs reuse the TMDB ids. They stay the same every time we rerun the pipeline, and they also turn out to be the key for linking, as you'll see next.
 TIẾNG VIỆT
-Bảng này cho thấy mỗi cột CSV được ánh xạ sang RDF thế nào. Cột id trở thành URI của phim, kiểu schema:Movie. Tiêu đề dùng Dublin Core, đạo diễn và diễn viên dùng DBpedia ontology, tên người dùng FOAF. Thể loại, hãng và quốc gia dùng term của nhóm. Có một lựa chọn thiết kế đáng chú ý: URI dùng lại id của TMDB. Nhờ vậy URI không đổi mỗi lần chạy lại pipeline, và id này còn chính là chìa khoá để liên kết, như slide tiếp theo.</a:t>
+Bảng này cho thấy mỗi cột CSV được ánh xạ sang RDF thế nào. Cột id trở thành URI của phim, kiểu schema:Movie. Tiêu đề dùng Dublin Core, đạo diễn và diễn viên dùng DBpedia ontology, tên người dùng FOAF. Thể loại, hãng và quốc gia dùng term của nhóm. Với diễn viên, nhóm vẫn giữ liên kết starring đơn giản, đồng thời tạo một CastRole cho mỗi diễn viên trong mỗi phim, kèm tên nhân vật và thứ tự trên danh sách. Có một lựa chọn thiết kế đáng chú ý: URI dùng lại id của TMDB. Nhờ vậy URI không đổi mỗi lần chạy lại pipeline, và id này còn chính là chìa khoá để liên kết, như slide tiếp theo.</a:t>
             </a:r>
             <a:endParaRPr lang="en-US" dirty="0"/>
           </a:p>
@@ -1510,9 +1510,9 @@
               <a:rPr lang="en-US" dirty="0"/>
               <a:t>Minh · ~40 s
 ENGLISH
-Thanks, Đức. You can query the graph in two ways: from the terminal with our sparql_cli script, or in Protégé's SPARQL tab. Here's query three, which answers 'which director has the most movies'. Steven Spielberg comes first with eight, followed by Tarantino and Nolan with seven each. We have five local queries — one per competency question, plus a check on the links — and ten federated queries that Chiến wrote.
+Thanks, Đức. You can query the graph in two ways: from the terminal with our sparql_cli script, or in Protégé's SPARQL tab. Here's query three, which answers 'which director has the most movies'. Steven Spielberg comes first with eight, followed by Tarantino and Nolan with seven each. Altogether there are 21 queries: five local ones — one per competency question, plus a check on the links — six on cast roles, and ten federated queries. Chiến wrote the cast-role and federated ones.
 TIẾNG VIỆT
-Cảm ơn Đức. Có hai cách truy vấn đồ thị: chạy trên terminal bằng script sparql_cli, hoặc dùng tab SPARQL trong Protégé. Đây là truy vấn số ba, trả lời câu hỏi đạo diễn nào có nhiều phim nhất. Steven Spielberg đứng đầu với tám phim, sau đó là Tarantino và Nolan, mỗi người bảy phim. Nhóm có năm truy vấn local — mỗi câu ứng với một competency question, thêm một câu kiểm tra liên kết — và mười truy vấn federated do Chiến viết.</a:t>
+Cảm ơn Đức. Có hai cách truy vấn đồ thị: chạy trên terminal bằng script sparql_cli, hoặc dùng tab SPARQL trong Protégé. Đây là truy vấn số ba, trả lời câu hỏi đạo diễn nào có nhiều phim nhất. Steven Spielberg đứng đầu với tám phim, sau đó là Tarantino và Nolan, mỗi người bảy phim. Tổng cộng có 21 truy vấn: năm truy vấn local — mỗi câu ứng với một competency question, thêm một câu kiểm tra liên kết — sáu truy vấn về vai diễn, và mười truy vấn federated. Phần vai diễn và federated do Chiến viết.</a:t>
             </a:r>
             <a:endParaRPr lang="en-US" dirty="0"/>
           </a:p>
@@ -1786,9 +1786,9 @@
               <a:rPr lang="en-US" dirty="0"/>
               <a:t>Đức · ~45 s
 ENGLISH
-To wrap up, a few honest limitations. First, Director and Actor are really roles, not types — by OntoClean's rigidity test, a hasRole property would be cleaner; we kept subclasses to stay simple. Second, we keep only one genre per film, so that the disjoint classes stay consistent. Third, our URIs live under example.org, so they don't resolve yet — publishing them behind a server like Fuseki is the natural next step. And finally, this is a snapshot of 250 films, with one film and one actor left unlinked because their ids were ambiguous.
+To wrap up, a few honest limitations. First, Director and Actor are really roles, not types — by OntoClean's rigidity test, a hasRole property would be cleaner; we kept subclasses to stay simple. Second, we keep only one genre per film, so that the disjoint classes stay consistent. Third, our URIs live under example.org, so they don't resolve yet — publishing them behind a server like Fuseki is the natural next step. And finally, this is a snapshot of 250 films, with one film and one actor left unlinked because their ids were ambiguous. Also, the character name is just a string, not a resource: TMDB only gives us a name, so two different characters called 'Sam' look the same — query 18 shows that.
 TIẾNG VIỆT
-Để kết lại, nhóm xin nêu thẳng vài giới hạn. Thứ nhất, Director và Actor thực chất là vai trò chứ không phải kiểu cố định — theo kiểm tra rigidity của OntoClean, dùng thuộc tính hasRole sẽ đúng hơn; nhóm giữ dạng lớp con cho đơn giản. Thứ hai, mỗi phim chỉ giữ một thể loại để các lớp disjoint không bị mâu thuẫn. Thứ ba, URI đang nằm dưới example.org nên chưa truy cập được — bước tiếp theo là công bố qua một server như Fuseki. Và cuối cùng, đây là bản chụp 250 phim, còn một phim và một diễn viên chưa được liên kết vì id bị mơ hồ.</a:t>
+Để kết lại, nhóm xin nêu thẳng vài giới hạn. Thứ nhất, Director và Actor thực chất là vai trò chứ không phải kiểu cố định — theo kiểm tra rigidity của OntoClean, dùng thuộc tính hasRole sẽ đúng hơn; nhóm giữ dạng lớp con cho đơn giản. Thứ hai, mỗi phim chỉ giữ một thể loại để các lớp disjoint không bị mâu thuẫn. Thứ ba, URI đang nằm dưới example.org nên chưa truy cập được — bước tiếp theo là công bố qua một server như Fuseki. Và cuối cùng, đây là bản chụp 250 phim, còn một phim và một diễn viên chưa được liên kết vì id bị mơ hồ. Ngoài ra, tên nhân vật chỉ là một chuỗi chứ không phải resource: TMDB chỉ cho tên, nên hai nhân vật khác nhau cùng tên 'Sam' trông như một — truy vấn 18 cho thấy điều đó.</a:t>
             </a:r>
             <a:endParaRPr lang="en-US" dirty="0"/>
           </a:p>
@@ -2338,9 +2338,9 @@
               <a:rPr lang="en-US" dirty="0"/>
               <a:t>Minh · ~60 s
 ENGLISH
-Here's the ontology. Movie sits in the middle. A movie has a director and actors, a genre, a studio and a country. Director and Actor are subclasses of Person, and a person can have an award. The dashed box at the bottom is the link out to Wikidata and DBpedia. On the right is the rule we followed: reuse existing vocabulary before minting our own. So Movie is schema.org's Movie, Person is FOAF's Person, director and starring come from the DBpedia ontology, and the title is Dublin Core. We only defined our own terms where nothing suitable existed, like hasGenre or releaseYear.
+Here's the ontology. Movie sits in the middle. A movie has a director and actors, a genre, a studio and a country. Director and Actor are subclasses of Person, and a person can have an award. The dashed box at the bottom is the link out to Wikidata and DBpedia. On the right is the rule we followed: reuse existing vocabulary before minting our own. So Movie is schema.org's Movie, Person is FOAF's Person, director and starring come from the DBpedia ontology, and the title is Dublin Core. We only defined our own terms where nothing suitable existed, like hasGenre or releaseYear. One more thing at the bottom left: a plain starring link can't say which character an actor plays, so each appearance of an actor in a movie is its own CastRole node, with the character name and the billing order. That's the n-ary relation pattern from the Knowledge Modeling lecture.
 TIẾNG VIỆT
-Đây là ontology. Movie nằm ở trung tâm. Mỗi phim có đạo diễn, diễn viên, thể loại, hãng sản xuất và quốc gia. Director và Actor là lớp con của Person, và một người có thể có giải thưởng. Ô nét đứt bên dưới là liên kết ra Wikidata và DBpedia. Bên phải là nguyên tắc nhóm áp dụng: dùng lại vocabulary có sẵn trước khi tự đặt term mới. Nên Movie là Movie của schema.org, Person là Person của FOAF, director và starring lấy từ DBpedia ontology, còn tiêu đề dùng Dublin Core. Nhóm chỉ tự định nghĩa khi không có term phù hợp, ví dụ hasGenre hay releaseYear.</a:t>
+Đây là ontology. Movie nằm ở trung tâm. Mỗi phim có đạo diễn, diễn viên, thể loại, hãng sản xuất và quốc gia. Director và Actor là lớp con của Person, và một người có thể có giải thưởng. Ô nét đứt bên dưới là liên kết ra Wikidata và DBpedia. Bên phải là nguyên tắc nhóm áp dụng: dùng lại vocabulary có sẵn trước khi tự đặt term mới. Nên Movie là Movie của schema.org, Person là Person của FOAF, director và starring lấy từ DBpedia ontology, còn tiêu đề dùng Dublin Core. Nhóm chỉ tự định nghĩa khi không có term phù hợp, ví dụ hasGenre hay releaseYear. Thêm một điểm ở góc dưới bên trái: một liên kết starring đơn thuần không nói được diễn viên đóng vai nào, nên mỗi lần một diễn viên xuất hiện trong một phim là một nút CastRole riêng, kèm tên nhân vật và thứ tự trên danh sách diễn viên. Đây chính là mẫu quan hệ n-ngôi trong bài Knowledge Modeling.</a:t>
             </a:r>
             <a:endParaRPr lang="en-US" dirty="0"/>
           </a:p>
@@ -2430,9 +2430,9 @@
               <a:rPr lang="en-US" dirty="0"/>
               <a:t>Minh · ~45 s
 ENGLISH
-This is the part we like most. Nobody in our data is tagged as an action movie or as an award-winning director. But once we run HermiT, the reasoner works it out by itself: 29 action movies, 16 comedies, 32 award-winning directors, and 5 people who directed and acted in the same film — Clint Eastwood is one of them. We get exactly the same numbers in Protégé and from our check_reasoning script.
+This is the part we like most. Nobody in our data is tagged as an action movie or as an award-winning director. But once we run HermiT, the reasoner works it out by itself: 29 action movies, 16 comedies, 32 award-winning directors, and 5 people who directed and acted in the same film — Clint Eastwood is one of them. These counts come from running HermiT in our check_reasoning script, and in the demo you'll see the same reasoner at work in Protégé.
 TIẾNG VIỆT
-Đây là phần nhóm thích nhất. Trong dữ liệu không có phim nào được gắn nhãn là phim hành động, cũng không có ai được gắn là đạo diễn đoạt giải. Nhưng khi chạy HermiT, reasoner tự suy ra: 29 phim hành động, 16 phim hài, 32 đạo diễn từng đoạt giải, và 5 người vừa đạo diễn vừa đóng trong cùng một phim — Clint Eastwood là một ví dụ. Số liệu trong Protégé và trong script check_reasoning trùng khớp hoàn toàn.</a:t>
+Đây là phần nhóm thích nhất. Trong dữ liệu không có phim nào được gắn nhãn là phim hành động, cũng không có ai được gắn là đạo diễn đoạt giải. Nhưng khi chạy HermiT, reasoner tự suy ra: 29 phim hành động, 16 phim hài, 32 đạo diễn từng đoạt giải, và 5 người vừa đạo diễn vừa đóng trong cùng một phim — Clint Eastwood là một ví dụ. Các con số này có được khi chạy HermiT bằng script check_reasoning, và trong phần demo mọi người sẽ thấy cùng reasoner đó chạy trong Protégé.</a:t>
             </a:r>
             <a:endParaRPr lang="en-US" dirty="0"/>
           </a:p>
@@ -3717,7 +3717,7 @@
       </p:sp>
       <p:sp>
         <p:nvSpPr>
-          <p:cNvPr id="3" name="text-158"/>
+          <p:cNvPr id="3" name="text-163"/>
           <p:cNvSpPr txBox="1"/>
           <p:nvPr/>
         </p:nvSpPr>
@@ -3756,7 +3756,7 @@
       </p:sp>
       <p:sp>
         <p:nvSpPr>
-          <p:cNvPr id="4" name="text-159"/>
+          <p:cNvPr id="4" name="text-164"/>
           <p:cNvSpPr txBox="1"/>
           <p:nvPr/>
         </p:nvSpPr>
@@ -3792,7 +3792,7 @@
       </p:sp>
       <p:sp>
         <p:nvSpPr>
-          <p:cNvPr id="5" name="text-160"/>
+          <p:cNvPr id="5" name="text-165"/>
           <p:cNvSpPr txBox="1"/>
           <p:nvPr/>
         </p:nvSpPr>
@@ -3831,7 +3831,7 @@
       </p:sp>
       <p:sp>
         <p:nvSpPr>
-          <p:cNvPr id="6" name="text-161"/>
+          <p:cNvPr id="6" name="text-166"/>
           <p:cNvSpPr txBox="1"/>
           <p:nvPr/>
         </p:nvSpPr>
@@ -3867,7 +3867,7 @@
       </p:sp>
       <p:sp>
         <p:nvSpPr>
-          <p:cNvPr id="7" name="text-162"/>
+          <p:cNvPr id="7" name="text-167"/>
           <p:cNvSpPr txBox="1"/>
           <p:nvPr/>
         </p:nvSpPr>
@@ -3906,7 +3906,7 @@
       </p:sp>
       <p:sp>
         <p:nvSpPr>
-          <p:cNvPr id="8" name="text-163"/>
+          <p:cNvPr id="8" name="text-168"/>
           <p:cNvSpPr txBox="1"/>
           <p:nvPr/>
         </p:nvSpPr>
@@ -3942,7 +3942,7 @@
       </p:sp>
       <p:sp>
         <p:nvSpPr>
-          <p:cNvPr id="9" name="text-164"/>
+          <p:cNvPr id="9" name="text-169"/>
           <p:cNvSpPr txBox="1"/>
           <p:nvPr/>
         </p:nvSpPr>
@@ -3981,7 +3981,7 @@
       </p:sp>
       <p:sp>
         <p:nvSpPr>
-          <p:cNvPr id="10" name="text-165"/>
+          <p:cNvPr id="10" name="text-170"/>
           <p:cNvSpPr txBox="1"/>
           <p:nvPr/>
         </p:nvSpPr>
@@ -4017,7 +4017,7 @@
       </p:sp>
       <p:sp>
         <p:nvSpPr>
-          <p:cNvPr id="11" name="text-166"/>
+          <p:cNvPr id="11" name="text-171"/>
           <p:cNvSpPr txBox="1"/>
           <p:nvPr/>
         </p:nvSpPr>
@@ -4204,7 +4204,7 @@
       </p:sp>
       <p:sp>
         <p:nvSpPr>
-          <p:cNvPr id="4" name="icon-bg-167"/>
+          <p:cNvPr id="4" name="icon-bg-172"/>
           <p:cNvSpPr/>
           <p:nvPr/>
         </p:nvSpPr>
@@ -4229,7 +4229,7 @@
       </p:sp>
       <p:pic>
         <p:nvPicPr>
-          <p:cNvPr id="5" name="icon-167" descr="preencoded.png">    </p:cNvPr>
+          <p:cNvPr id="5" name="icon-172" descr="preencoded.png">    </p:cNvPr>
           <p:cNvPicPr>
             <a:picLocks noChangeAspect="1"/>
           </p:cNvPicPr>
@@ -4253,7 +4253,7 @@
       </p:pic>
       <p:sp>
         <p:nvSpPr>
-          <p:cNvPr id="6" name="text-168"/>
+          <p:cNvPr id="6" name="text-173"/>
           <p:cNvSpPr txBox="1"/>
           <p:nvPr/>
         </p:nvSpPr>
@@ -4289,7 +4289,7 @@
       </p:sp>
       <p:sp>
         <p:nvSpPr>
-          <p:cNvPr id="7" name="text-169"/>
+          <p:cNvPr id="7" name="text-174"/>
           <p:cNvSpPr txBox="1"/>
           <p:nvPr/>
         </p:nvSpPr>
@@ -4328,7 +4328,7 @@
       </p:sp>
       <p:sp>
         <p:nvSpPr>
-          <p:cNvPr id="8" name="text-170"/>
+          <p:cNvPr id="8" name="text-175"/>
           <p:cNvSpPr txBox="1"/>
           <p:nvPr/>
         </p:nvSpPr>
@@ -4415,7 +4415,7 @@
       </p:sp>
       <p:sp>
         <p:nvSpPr>
-          <p:cNvPr id="11" name="icon-bg-171"/>
+          <p:cNvPr id="11" name="icon-bg-176"/>
           <p:cNvSpPr/>
           <p:nvPr/>
         </p:nvSpPr>
@@ -4440,7 +4440,7 @@
       </p:sp>
       <p:pic>
         <p:nvPicPr>
-          <p:cNvPr id="12" name="icon-171" descr="preencoded.png">    </p:cNvPr>
+          <p:cNvPr id="12" name="icon-176" descr="preencoded.png">    </p:cNvPr>
           <p:cNvPicPr>
             <a:picLocks noChangeAspect="1"/>
           </p:cNvPicPr>
@@ -4464,7 +4464,7 @@
       </p:pic>
       <p:sp>
         <p:nvSpPr>
-          <p:cNvPr id="13" name="text-172"/>
+          <p:cNvPr id="13" name="text-177"/>
           <p:cNvSpPr txBox="1"/>
           <p:nvPr/>
         </p:nvSpPr>
@@ -4500,7 +4500,7 @@
       </p:sp>
       <p:sp>
         <p:nvSpPr>
-          <p:cNvPr id="14" name="text-173"/>
+          <p:cNvPr id="14" name="text-178"/>
           <p:cNvSpPr txBox="1"/>
           <p:nvPr/>
         </p:nvSpPr>
@@ -4539,7 +4539,7 @@
       </p:sp>
       <p:sp>
         <p:nvSpPr>
-          <p:cNvPr id="15" name="text-174"/>
+          <p:cNvPr id="15" name="text-179"/>
           <p:cNvSpPr txBox="1"/>
           <p:nvPr/>
         </p:nvSpPr>
@@ -4626,7 +4626,7 @@
       </p:sp>
       <p:sp>
         <p:nvSpPr>
-          <p:cNvPr id="18" name="icon-bg-175"/>
+          <p:cNvPr id="18" name="icon-bg-180"/>
           <p:cNvSpPr/>
           <p:nvPr/>
         </p:nvSpPr>
@@ -4651,7 +4651,7 @@
       </p:sp>
       <p:pic>
         <p:nvPicPr>
-          <p:cNvPr id="19" name="icon-175" descr="preencoded.png">    </p:cNvPr>
+          <p:cNvPr id="19" name="icon-180" descr="preencoded.png">    </p:cNvPr>
           <p:cNvPicPr>
             <a:picLocks noChangeAspect="1"/>
           </p:cNvPicPr>
@@ -4675,7 +4675,7 @@
       </p:pic>
       <p:sp>
         <p:nvSpPr>
-          <p:cNvPr id="20" name="text-176"/>
+          <p:cNvPr id="20" name="text-181"/>
           <p:cNvSpPr txBox="1"/>
           <p:nvPr/>
         </p:nvSpPr>
@@ -4711,7 +4711,7 @@
       </p:sp>
       <p:sp>
         <p:nvSpPr>
-          <p:cNvPr id="21" name="text-177"/>
+          <p:cNvPr id="21" name="text-182"/>
           <p:cNvSpPr txBox="1"/>
           <p:nvPr/>
         </p:nvSpPr>
@@ -4750,7 +4750,7 @@
       </p:sp>
       <p:sp>
         <p:nvSpPr>
-          <p:cNvPr id="22" name="text-178"/>
+          <p:cNvPr id="22" name="text-183"/>
           <p:cNvSpPr txBox="1"/>
           <p:nvPr/>
         </p:nvSpPr>
@@ -4778,7 +4778,7 @@
                   <a:schemeClr val="accent4"/>
                 </a:solidFill>
               </a:rPr>
-              <a:t>movies_linked.ttl, 6,618 triples</a:t>
+              <a:t>movies_linked.ttl, 11,868 triples</a:t>
             </a:r>
             <a:endParaRPr lang="en-US" sz="1300" dirty="0"/>
           </a:p>
@@ -4837,7 +4837,7 @@
       </p:sp>
       <p:sp>
         <p:nvSpPr>
-          <p:cNvPr id="25" name="icon-bg-179"/>
+          <p:cNvPr id="25" name="icon-bg-184"/>
           <p:cNvSpPr/>
           <p:nvPr/>
         </p:nvSpPr>
@@ -4862,7 +4862,7 @@
       </p:sp>
       <p:pic>
         <p:nvPicPr>
-          <p:cNvPr id="26" name="icon-179" descr="preencoded.png">    </p:cNvPr>
+          <p:cNvPr id="26" name="icon-184" descr="preencoded.png">    </p:cNvPr>
           <p:cNvPicPr>
             <a:picLocks noChangeAspect="1"/>
           </p:cNvPicPr>
@@ -4886,7 +4886,7 @@
       </p:pic>
       <p:sp>
         <p:nvSpPr>
-          <p:cNvPr id="27" name="text-180"/>
+          <p:cNvPr id="27" name="text-185"/>
           <p:cNvSpPr txBox="1"/>
           <p:nvPr/>
         </p:nvSpPr>
@@ -4922,7 +4922,7 @@
       </p:sp>
       <p:sp>
         <p:nvSpPr>
-          <p:cNvPr id="28" name="text-181"/>
+          <p:cNvPr id="28" name="text-186"/>
           <p:cNvSpPr txBox="1"/>
           <p:nvPr/>
         </p:nvSpPr>
@@ -4961,7 +4961,7 @@
       </p:sp>
       <p:sp>
         <p:nvSpPr>
-          <p:cNvPr id="29" name="text-182"/>
+          <p:cNvPr id="29" name="text-187"/>
           <p:cNvSpPr txBox="1"/>
           <p:nvPr/>
         </p:nvSpPr>
@@ -5024,7 +5024,7 @@
       </p:sp>
       <p:sp>
         <p:nvSpPr>
-          <p:cNvPr id="31" name="text-183"/>
+          <p:cNvPr id="31" name="text-188"/>
           <p:cNvSpPr txBox="1"/>
           <p:nvPr/>
         </p:nvSpPr>
@@ -6276,7 +6276,7 @@
                           <a:ea typeface="Calibri" pitchFamily="34" charset="-122"/>
                           <a:cs typeface="Calibri" pitchFamily="34" charset="-120"/>
                         </a:rPr>
-                        <a:t>cast_ids, cast_names</a:t>
+                        <a:t>cast_ids, cast_names, cast_characters</a:t>
                       </a:r>
                       <a:endParaRPr lang="en-US" sz="1400" dirty="0">
                         <a:latin typeface="Calibri" charset="0"/>
@@ -6341,7 +6341,7 @@
                           <a:ea typeface="Courier New" pitchFamily="34" charset="-122"/>
                           <a:cs typeface="Courier New" pitchFamily="34" charset="-120"/>
                         </a:rPr>
-                        <a:t>dbo:starring  (top 3 billed)</a:t>
+                        <a:t>dbo:starring;  ont:CastRole (characterName, billingOrder)</a:t>
                       </a:r>
                       <a:endParaRPr lang="en-US" sz="1300" dirty="0">
                         <a:latin typeface="Courier New" charset="0"/>
@@ -6406,7 +6406,7 @@
                           <a:ea typeface="Calibri" pitchFamily="34" charset="-122"/>
                           <a:cs typeface="Calibri" pitchFamily="34" charset="-120"/>
                         </a:rPr>
-                        <a:t>DBpedia</a:t>
+                        <a:t>DBpedia, local</a:t>
                       </a:r>
                       <a:endParaRPr lang="en-US" sz="1400" dirty="0">
                         <a:latin typeface="Calibri" charset="0"/>
@@ -7052,7 +7052,7 @@
       </p:graphicFrame>
       <p:sp>
         <p:nvSpPr>
-          <p:cNvPr id="4" name="icon-bg-184"/>
+          <p:cNvPr id="4" name="icon-bg-189"/>
           <p:cNvSpPr/>
           <p:nvPr/>
         </p:nvSpPr>
@@ -7077,7 +7077,7 @@
       </p:sp>
       <p:pic>
         <p:nvPicPr>
-          <p:cNvPr id="5" name="icon-184" descr="preencoded.png">    </p:cNvPr>
+          <p:cNvPr id="5" name="icon-189" descr="preencoded.png">    </p:cNvPr>
           <p:cNvPicPr>
             <a:picLocks noChangeAspect="1"/>
           </p:cNvPicPr>
@@ -7101,7 +7101,7 @@
       </p:pic>
       <p:sp>
         <p:nvSpPr>
-          <p:cNvPr id="6" name="text-185"/>
+          <p:cNvPr id="6" name="text-190"/>
           <p:cNvSpPr txBox="1"/>
           <p:nvPr/>
         </p:nvSpPr>
@@ -7272,7 +7272,7 @@
       </p:sp>
       <p:sp>
         <p:nvSpPr>
-          <p:cNvPr id="4" name="icon-bg-186"/>
+          <p:cNvPr id="4" name="icon-bg-191"/>
           <p:cNvSpPr/>
           <p:nvPr/>
         </p:nvSpPr>
@@ -7297,7 +7297,7 @@
       </p:sp>
       <p:pic>
         <p:nvPicPr>
-          <p:cNvPr id="5" name="icon-186" descr="preencoded.png">    </p:cNvPr>
+          <p:cNvPr id="5" name="icon-191" descr="preencoded.png">    </p:cNvPr>
           <p:cNvPicPr>
             <a:picLocks noChangeAspect="1"/>
           </p:cNvPicPr>
@@ -7321,7 +7321,7 @@
       </p:pic>
       <p:sp>
         <p:nvSpPr>
-          <p:cNvPr id="6" name="text-187"/>
+          <p:cNvPr id="6" name="text-192"/>
           <p:cNvSpPr txBox="1"/>
           <p:nvPr/>
         </p:nvSpPr>
@@ -7357,7 +7357,7 @@
       </p:sp>
       <p:sp>
         <p:nvSpPr>
-          <p:cNvPr id="7" name="text-188"/>
+          <p:cNvPr id="7" name="text-193"/>
           <p:cNvSpPr txBox="1"/>
           <p:nvPr/>
         </p:nvSpPr>
@@ -7420,7 +7420,7 @@
       </p:sp>
       <p:sp>
         <p:nvSpPr>
-          <p:cNvPr id="9" name="icon-bg-189"/>
+          <p:cNvPr id="9" name="icon-bg-194"/>
           <p:cNvSpPr/>
           <p:nvPr/>
         </p:nvSpPr>
@@ -7445,7 +7445,7 @@
       </p:sp>
       <p:pic>
         <p:nvPicPr>
-          <p:cNvPr id="10" name="icon-189" descr="preencoded.png">    </p:cNvPr>
+          <p:cNvPr id="10" name="icon-194" descr="preencoded.png">    </p:cNvPr>
           <p:cNvPicPr>
             <a:picLocks noChangeAspect="1"/>
           </p:cNvPicPr>
@@ -7469,7 +7469,7 @@
       </p:pic>
       <p:sp>
         <p:nvSpPr>
-          <p:cNvPr id="11" name="text-190"/>
+          <p:cNvPr id="11" name="text-195"/>
           <p:cNvSpPr txBox="1"/>
           <p:nvPr/>
         </p:nvSpPr>
@@ -7505,7 +7505,7 @@
       </p:sp>
       <p:sp>
         <p:nvSpPr>
-          <p:cNvPr id="12" name="text-191"/>
+          <p:cNvPr id="12" name="text-196"/>
           <p:cNvSpPr txBox="1"/>
           <p:nvPr/>
         </p:nvSpPr>
@@ -7581,7 +7581,7 @@
       </p:sp>
       <p:sp>
         <p:nvSpPr>
-          <p:cNvPr id="13" name="text-192"/>
+          <p:cNvPr id="13" name="text-197"/>
           <p:cNvSpPr txBox="1"/>
           <p:nvPr/>
         </p:nvSpPr>
@@ -7620,7 +7620,7 @@
       </p:sp>
       <p:sp>
         <p:nvSpPr>
-          <p:cNvPr id="14" name="text-193"/>
+          <p:cNvPr id="14" name="text-198"/>
           <p:cNvSpPr txBox="1"/>
           <p:nvPr/>
         </p:nvSpPr>
@@ -7656,7 +7656,7 @@
       </p:sp>
       <p:sp>
         <p:nvSpPr>
-          <p:cNvPr id="15" name="text-194"/>
+          <p:cNvPr id="15" name="text-199"/>
           <p:cNvSpPr txBox="1"/>
           <p:nvPr/>
         </p:nvSpPr>
@@ -7695,7 +7695,7 @@
       </p:sp>
       <p:sp>
         <p:nvSpPr>
-          <p:cNvPr id="16" name="text-195"/>
+          <p:cNvPr id="16" name="text-200"/>
           <p:cNvSpPr txBox="1"/>
           <p:nvPr/>
         </p:nvSpPr>
@@ -7731,7 +7731,7 @@
       </p:sp>
       <p:sp>
         <p:nvSpPr>
-          <p:cNvPr id="17" name="text-196"/>
+          <p:cNvPr id="17" name="text-201"/>
           <p:cNvSpPr txBox="1"/>
           <p:nvPr/>
         </p:nvSpPr>
@@ -7770,7 +7770,7 @@
       </p:sp>
       <p:sp>
         <p:nvSpPr>
-          <p:cNvPr id="18" name="text-197"/>
+          <p:cNvPr id="18" name="text-202"/>
           <p:cNvSpPr txBox="1"/>
           <p:nvPr/>
         </p:nvSpPr>
@@ -7941,7 +7941,7 @@
       </p:sp>
       <p:sp>
         <p:nvSpPr>
-          <p:cNvPr id="4" name="text-198"/>
+          <p:cNvPr id="4" name="text-203"/>
           <p:cNvSpPr txBox="1"/>
           <p:nvPr/>
         </p:nvSpPr>
@@ -7980,7 +7980,7 @@
       </p:sp>
       <p:sp>
         <p:nvSpPr>
-          <p:cNvPr id="5" name="text-199"/>
+          <p:cNvPr id="5" name="text-204"/>
           <p:cNvSpPr txBox="1"/>
           <p:nvPr/>
         </p:nvSpPr>
@@ -8016,7 +8016,7 @@
       </p:sp>
       <p:sp>
         <p:nvSpPr>
-          <p:cNvPr id="6" name="text-200"/>
+          <p:cNvPr id="6" name="text-205"/>
           <p:cNvSpPr txBox="1"/>
           <p:nvPr/>
         </p:nvSpPr>
@@ -8079,7 +8079,7 @@
       </p:sp>
       <p:sp>
         <p:nvSpPr>
-          <p:cNvPr id="8" name="text-201"/>
+          <p:cNvPr id="8" name="text-206"/>
           <p:cNvSpPr txBox="1"/>
           <p:nvPr/>
         </p:nvSpPr>
@@ -8118,7 +8118,7 @@
       </p:sp>
       <p:sp>
         <p:nvSpPr>
-          <p:cNvPr id="9" name="text-202"/>
+          <p:cNvPr id="9" name="text-207"/>
           <p:cNvSpPr txBox="1"/>
           <p:nvPr/>
         </p:nvSpPr>
@@ -8154,7 +8154,7 @@
       </p:sp>
       <p:sp>
         <p:nvSpPr>
-          <p:cNvPr id="10" name="text-203"/>
+          <p:cNvPr id="10" name="text-208"/>
           <p:cNvSpPr txBox="1"/>
           <p:nvPr/>
         </p:nvSpPr>
@@ -8190,7 +8190,7 @@
       </p:sp>
       <p:sp>
         <p:nvSpPr>
-          <p:cNvPr id="11" name="text-204"/>
+          <p:cNvPr id="11" name="text-209"/>
           <p:cNvSpPr txBox="1"/>
           <p:nvPr/>
         </p:nvSpPr>
@@ -8253,7 +8253,7 @@
       </p:sp>
       <p:sp>
         <p:nvSpPr>
-          <p:cNvPr id="13" name="icon-bg-205"/>
+          <p:cNvPr id="13" name="icon-bg-210"/>
           <p:cNvSpPr/>
           <p:nvPr/>
         </p:nvSpPr>
@@ -8278,7 +8278,7 @@
       </p:sp>
       <p:pic>
         <p:nvPicPr>
-          <p:cNvPr id="14" name="icon-205" descr="preencoded.png">    </p:cNvPr>
+          <p:cNvPr id="14" name="icon-210" descr="preencoded.png">    </p:cNvPr>
           <p:cNvPicPr>
             <a:picLocks noChangeAspect="1"/>
           </p:cNvPicPr>
@@ -8302,7 +8302,7 @@
       </p:pic>
       <p:sp>
         <p:nvSpPr>
-          <p:cNvPr id="15" name="text-206"/>
+          <p:cNvPr id="15" name="text-211"/>
           <p:cNvSpPr txBox="1"/>
           <p:nvPr/>
         </p:nvSpPr>
@@ -8338,7 +8338,7 @@
       </p:sp>
       <p:sp>
         <p:nvSpPr>
-          <p:cNvPr id="16" name="text-207"/>
+          <p:cNvPr id="16" name="text-212"/>
           <p:cNvSpPr txBox="1"/>
           <p:nvPr/>
         </p:nvSpPr>
@@ -8374,7 +8374,7 @@
       </p:sp>
       <p:sp>
         <p:nvSpPr>
-          <p:cNvPr id="17" name="text-208"/>
+          <p:cNvPr id="17" name="text-213"/>
           <p:cNvSpPr txBox="1"/>
           <p:nvPr/>
         </p:nvSpPr>
@@ -8468,7 +8468,7 @@
       </p:sp>
       <p:sp>
         <p:nvSpPr>
-          <p:cNvPr id="18" name="text-209"/>
+          <p:cNvPr id="18" name="text-214"/>
           <p:cNvSpPr txBox="1"/>
           <p:nvPr/>
         </p:nvSpPr>
@@ -8639,7 +8639,7 @@
       </p:sp>
       <p:sp>
         <p:nvSpPr>
-          <p:cNvPr id="4" name="icon-bg-210"/>
+          <p:cNvPr id="4" name="icon-bg-215"/>
           <p:cNvSpPr/>
           <p:nvPr/>
         </p:nvSpPr>
@@ -8664,7 +8664,7 @@
       </p:sp>
       <p:pic>
         <p:nvPicPr>
-          <p:cNvPr id="5" name="icon-210" descr="preencoded.png">    </p:cNvPr>
+          <p:cNvPr id="5" name="icon-215" descr="preencoded.png">    </p:cNvPr>
           <p:cNvPicPr>
             <a:picLocks noChangeAspect="1"/>
           </p:cNvPicPr>
@@ -8688,7 +8688,7 @@
       </p:pic>
       <p:sp>
         <p:nvSpPr>
-          <p:cNvPr id="6" name="text-211"/>
+          <p:cNvPr id="6" name="text-216"/>
           <p:cNvSpPr txBox="1"/>
           <p:nvPr/>
         </p:nvSpPr>
@@ -8724,7 +8724,7 @@
       </p:sp>
       <p:sp>
         <p:nvSpPr>
-          <p:cNvPr id="7" name="text-212"/>
+          <p:cNvPr id="7" name="text-217"/>
           <p:cNvSpPr txBox="1"/>
           <p:nvPr/>
         </p:nvSpPr>
@@ -8787,7 +8787,7 @@
       </p:sp>
       <p:sp>
         <p:nvSpPr>
-          <p:cNvPr id="9" name="icon-bg-213"/>
+          <p:cNvPr id="9" name="icon-bg-218"/>
           <p:cNvSpPr/>
           <p:nvPr/>
         </p:nvSpPr>
@@ -8812,7 +8812,7 @@
       </p:sp>
       <p:pic>
         <p:nvPicPr>
-          <p:cNvPr id="10" name="icon-213" descr="preencoded.png">    </p:cNvPr>
+          <p:cNvPr id="10" name="icon-218" descr="preencoded.png">    </p:cNvPr>
           <p:cNvPicPr>
             <a:picLocks noChangeAspect="1"/>
           </p:cNvPicPr>
@@ -8836,7 +8836,7 @@
       </p:pic>
       <p:sp>
         <p:nvSpPr>
-          <p:cNvPr id="11" name="text-214"/>
+          <p:cNvPr id="11" name="text-219"/>
           <p:cNvSpPr txBox="1"/>
           <p:nvPr/>
         </p:nvSpPr>
@@ -8872,7 +8872,7 @@
       </p:sp>
       <p:sp>
         <p:nvSpPr>
-          <p:cNvPr id="12" name="text-215"/>
+          <p:cNvPr id="12" name="text-220"/>
           <p:cNvSpPr txBox="1"/>
           <p:nvPr/>
         </p:nvSpPr>
@@ -8935,7 +8935,7 @@
       </p:sp>
       <p:sp>
         <p:nvSpPr>
-          <p:cNvPr id="14" name="icon-bg-216"/>
+          <p:cNvPr id="14" name="icon-bg-221"/>
           <p:cNvSpPr/>
           <p:nvPr/>
         </p:nvSpPr>
@@ -8960,7 +8960,7 @@
       </p:sp>
       <p:pic>
         <p:nvPicPr>
-          <p:cNvPr id="15" name="icon-216" descr="preencoded.png">    </p:cNvPr>
+          <p:cNvPr id="15" name="icon-221" descr="preencoded.png">    </p:cNvPr>
           <p:cNvPicPr>
             <a:picLocks noChangeAspect="1"/>
           </p:cNvPicPr>
@@ -8984,7 +8984,7 @@
       </p:pic>
       <p:sp>
         <p:nvSpPr>
-          <p:cNvPr id="16" name="text-217"/>
+          <p:cNvPr id="16" name="text-222"/>
           <p:cNvSpPr txBox="1"/>
           <p:nvPr/>
         </p:nvSpPr>
@@ -9020,7 +9020,7 @@
       </p:sp>
       <p:sp>
         <p:nvSpPr>
-          <p:cNvPr id="17" name="text-218"/>
+          <p:cNvPr id="17" name="text-223"/>
           <p:cNvSpPr txBox="1"/>
           <p:nvPr/>
         </p:nvSpPr>
@@ -9056,7 +9056,7 @@
       </p:sp>
       <p:sp>
         <p:nvSpPr>
-          <p:cNvPr id="18" name="text-219"/>
+          <p:cNvPr id="18" name="text-224"/>
           <p:cNvSpPr txBox="1"/>
           <p:nvPr/>
         </p:nvSpPr>
@@ -9782,7 +9782,7 @@
       </p:graphicFrame>
       <p:sp>
         <p:nvSpPr>
-          <p:cNvPr id="20" name="text-220"/>
+          <p:cNvPr id="20" name="text-225"/>
           <p:cNvSpPr txBox="1"/>
           <p:nvPr/>
         </p:nvSpPr>
@@ -9953,7 +9953,7 @@
       </p:sp>
       <p:sp>
         <p:nvSpPr>
-          <p:cNvPr id="4" name="text-221"/>
+          <p:cNvPr id="4" name="text-226"/>
           <p:cNvSpPr txBox="1"/>
           <p:nvPr/>
         </p:nvSpPr>
@@ -10946,7 +10946,7 @@
         <p:spPr>
           <a:xfrm>
             <a:off x="548640" y="4983480"/>
-            <a:ext cx="3514344" cy="1143000"/>
+            <a:ext cx="2567178" cy="1143000"/>
           </a:xfrm>
           <a:prstGeom prst="roundRect">
             <a:avLst>
@@ -10966,14 +10966,14 @@
       </p:sp>
       <p:sp>
         <p:nvSpPr>
-          <p:cNvPr id="7" name="text-222"/>
+          <p:cNvPr id="7" name="text-227"/>
           <p:cNvSpPr txBox="1"/>
           <p:nvPr/>
         </p:nvSpPr>
         <p:spPr>
           <a:xfrm>
             <a:off x="777240" y="5074920"/>
-            <a:ext cx="3057144" cy="365760"/>
+            <a:ext cx="2109978" cy="365760"/>
           </a:xfrm>
           <a:prstGeom prst="rect">
             <a:avLst/>
@@ -11002,14 +11002,14 @@
       </p:sp>
       <p:sp>
         <p:nvSpPr>
-          <p:cNvPr id="8" name="text-223"/>
+          <p:cNvPr id="8" name="text-228"/>
           <p:cNvSpPr txBox="1"/>
           <p:nvPr/>
         </p:nvSpPr>
         <p:spPr>
           <a:xfrm>
             <a:off x="777240" y="5440680"/>
-            <a:ext cx="3057144" cy="594360"/>
+            <a:ext cx="2109978" cy="594360"/>
           </a:xfrm>
           <a:prstGeom prst="rect">
             <a:avLst/>
@@ -11044,8 +11044,8 @@
         </p:nvSpPr>
         <p:spPr>
           <a:xfrm>
-            <a:off x="4337304" y="4983480"/>
-            <a:ext cx="3514344" cy="1143000"/>
+            <a:off x="3390138" y="4983480"/>
+            <a:ext cx="2567178" cy="1143000"/>
           </a:xfrm>
           <a:prstGeom prst="roundRect">
             <a:avLst>
@@ -11065,14 +11065,14 @@
       </p:sp>
       <p:sp>
         <p:nvSpPr>
-          <p:cNvPr id="10" name="text-224"/>
+          <p:cNvPr id="10" name="text-229"/>
           <p:cNvSpPr txBox="1"/>
           <p:nvPr/>
         </p:nvSpPr>
         <p:spPr>
           <a:xfrm>
-            <a:off x="4565904" y="5074920"/>
-            <a:ext cx="3057144" cy="365760"/>
+            <a:off x="3618738" y="5074920"/>
+            <a:ext cx="2109978" cy="365760"/>
           </a:xfrm>
           <a:prstGeom prst="rect">
             <a:avLst/>
@@ -11093,7 +11093,7 @@
                   <a:schemeClr val="accent1"/>
                 </a:solidFill>
               </a:rPr>
-              <a:t>10 federated queries</a:t>
+              <a:t>6 cast-role queries</a:t>
             </a:r>
             <a:endParaRPr lang="en-US" sz="1600" dirty="0"/>
           </a:p>
@@ -11101,14 +11101,14 @@
       </p:sp>
       <p:sp>
         <p:nvSpPr>
-          <p:cNvPr id="11" name="text-225"/>
+          <p:cNvPr id="11" name="text-230"/>
           <p:cNvSpPr txBox="1"/>
           <p:nvPr/>
         </p:nvSpPr>
         <p:spPr>
           <a:xfrm>
-            <a:off x="4565904" y="5440680"/>
-            <a:ext cx="3057144" cy="594360"/>
+            <a:off x="3618738" y="5440680"/>
+            <a:ext cx="2109978" cy="594360"/>
           </a:xfrm>
           <a:prstGeom prst="rect">
             <a:avLst/>
@@ -11129,7 +11129,7 @@
                   <a:schemeClr val="accent4"/>
                 </a:solidFill>
               </a:rPr>
-              <a:t>SERVICE calls to Wikidata and DBpedia: birth dates, box office, abstracts</a:t>
+              <a:t>characters and billing order through the n-ary CastRole</a:t>
             </a:r>
             <a:endParaRPr lang="en-US" sz="1300" dirty="0"/>
           </a:p>
@@ -11143,8 +11143,8 @@
         </p:nvSpPr>
         <p:spPr>
           <a:xfrm>
-            <a:off x="8125968" y="4983480"/>
-            <a:ext cx="3514344" cy="1143000"/>
+            <a:off x="6231636" y="4983480"/>
+            <a:ext cx="2567178" cy="1143000"/>
           </a:xfrm>
           <a:prstGeom prst="roundRect">
             <a:avLst>
@@ -11164,14 +11164,14 @@
       </p:sp>
       <p:sp>
         <p:nvSpPr>
-          <p:cNvPr id="13" name="text-226"/>
+          <p:cNvPr id="13" name="text-231"/>
           <p:cNvSpPr txBox="1"/>
           <p:nvPr/>
         </p:nvSpPr>
         <p:spPr>
           <a:xfrm>
-            <a:off x="8354568" y="5074920"/>
-            <a:ext cx="3057144" cy="365760"/>
+            <a:off x="6460236" y="5074920"/>
+            <a:ext cx="2109978" cy="365760"/>
           </a:xfrm>
           <a:prstGeom prst="rect">
             <a:avLst/>
@@ -11192,7 +11192,7 @@
                   <a:schemeClr val="accent1"/>
                 </a:solidFill>
               </a:rPr>
-              <a:t>Two interfaces</a:t>
+              <a:t>10 federated queries</a:t>
             </a:r>
             <a:endParaRPr lang="en-US" sz="1600" dirty="0"/>
           </a:p>
@@ -11200,14 +11200,14 @@
       </p:sp>
       <p:sp>
         <p:nvSpPr>
-          <p:cNvPr id="14" name="text-227"/>
+          <p:cNvPr id="14" name="text-232"/>
           <p:cNvSpPr txBox="1"/>
           <p:nvPr/>
         </p:nvSpPr>
         <p:spPr>
           <a:xfrm>
-            <a:off x="8354568" y="5440680"/>
-            <a:ext cx="3057144" cy="594360"/>
+            <a:off x="6460236" y="5440680"/>
+            <a:ext cx="2109978" cy="594360"/>
           </a:xfrm>
           <a:prstGeom prst="rect">
             <a:avLst/>
@@ -11228,7 +11228,106 @@
                   <a:schemeClr val="accent4"/>
                 </a:solidFill>
               </a:rPr>
-              <a:t>python scripts/sparql_cli.py in a terminal, and Protégé's SPARQL tab</a:t>
+              <a:t>SERVICE calls to Wikidata and DBpedia</a:t>
+            </a:r>
+            <a:endParaRPr lang="en-US" sz="1300" dirty="0"/>
+          </a:p>
+        </p:txBody>
+      </p:sp>
+      <p:sp>
+        <p:nvSpPr>
+          <p:cNvPr id="15" name="query-chip-4"/>
+          <p:cNvSpPr/>
+          <p:nvPr/>
+        </p:nvSpPr>
+        <p:spPr>
+          <a:xfrm>
+            <a:off x="9073134" y="4983480"/>
+            <a:ext cx="2567178" cy="1143000"/>
+          </a:xfrm>
+          <a:prstGeom prst="roundRect">
+            <a:avLst>
+              <a:gd name="adj" fmla="val 6400"/>
+            </a:avLst>
+          </a:prstGeom>
+          <a:solidFill>
+            <a:schemeClr val="bg2"/>
+          </a:solidFill>
+          <a:ln w="12700">
+            <a:solidFill>
+              <a:srgbClr val="F3F4F6"/>
+            </a:solidFill>
+            <a:prstDash val="solid"/>
+          </a:ln>
+        </p:spPr>
+      </p:sp>
+      <p:sp>
+        <p:nvSpPr>
+          <p:cNvPr id="16" name="text-233"/>
+          <p:cNvSpPr txBox="1"/>
+          <p:nvPr/>
+        </p:nvSpPr>
+        <p:spPr>
+          <a:xfrm>
+            <a:off x="9301734" y="5074920"/>
+            <a:ext cx="2109978" cy="365760"/>
+          </a:xfrm>
+          <a:prstGeom prst="rect">
+            <a:avLst/>
+          </a:prstGeom>
+          <a:noFill/>
+          <a:ln/>
+        </p:spPr>
+        <p:txBody>
+          <a:bodyPr wrap="square" lIns="0" tIns="0" rIns="0" bIns="0" rtlCol="0" anchor="ctr"/>
+          <a:lstStyle/>
+          <a:p>
+            <a:pPr indent="0" marL="0">
+              <a:buNone/>
+            </a:pPr>
+            <a:r>
+              <a:rPr lang="en-US" sz="1600" b="1" dirty="0">
+                <a:solidFill>
+                  <a:schemeClr val="accent1"/>
+                </a:solidFill>
+              </a:rPr>
+              <a:t>Two interfaces</a:t>
+            </a:r>
+            <a:endParaRPr lang="en-US" sz="1600" dirty="0"/>
+          </a:p>
+        </p:txBody>
+      </p:sp>
+      <p:sp>
+        <p:nvSpPr>
+          <p:cNvPr id="17" name="text-234"/>
+          <p:cNvSpPr txBox="1"/>
+          <p:nvPr/>
+        </p:nvSpPr>
+        <p:spPr>
+          <a:xfrm>
+            <a:off x="9301734" y="5440680"/>
+            <a:ext cx="2109978" cy="594360"/>
+          </a:xfrm>
+          <a:prstGeom prst="rect">
+            <a:avLst/>
+          </a:prstGeom>
+          <a:noFill/>
+          <a:ln/>
+        </p:spPr>
+        <p:txBody>
+          <a:bodyPr wrap="square" lIns="0" tIns="0" rIns="0" bIns="0" rtlCol="0" anchor="t"/>
+          <a:lstStyle/>
+          <a:p>
+            <a:pPr indent="0" marL="0">
+              <a:buNone/>
+            </a:pPr>
+            <a:r>
+              <a:rPr lang="en-US" sz="1300" dirty="0">
+                <a:solidFill>
+                  <a:schemeClr val="accent4"/>
+                </a:solidFill>
+              </a:rPr>
+              <a:t>sparql_cli.py in a terminal, and Protégé's SPARQL tab</a:t>
             </a:r>
             <a:endParaRPr lang="en-US" sz="1300" dirty="0"/>
           </a:p>
@@ -11371,7 +11470,7 @@
       </p:sp>
       <p:sp>
         <p:nvSpPr>
-          <p:cNvPr id="4" name="text-228"/>
+          <p:cNvPr id="4" name="text-235"/>
           <p:cNvSpPr txBox="1"/>
           <p:nvPr/>
         </p:nvSpPr>
@@ -13179,7 +13278,7 @@
       </p:graphicFrame>
       <p:sp>
         <p:nvSpPr>
-          <p:cNvPr id="6" name="text-229"/>
+          <p:cNvPr id="6" name="text-236"/>
           <p:cNvSpPr txBox="1"/>
           <p:nvPr/>
         </p:nvSpPr>
@@ -13215,7 +13314,7 @@
       </p:sp>
       <p:sp>
         <p:nvSpPr>
-          <p:cNvPr id="7" name="icon-bg-230"/>
+          <p:cNvPr id="7" name="icon-bg-237"/>
           <p:cNvSpPr/>
           <p:nvPr/>
         </p:nvSpPr>
@@ -13240,7 +13339,7 @@
       </p:sp>
       <p:pic>
         <p:nvPicPr>
-          <p:cNvPr id="8" name="icon-230" descr="preencoded.png">    </p:cNvPr>
+          <p:cNvPr id="8" name="icon-237" descr="preencoded.png">    </p:cNvPr>
           <p:cNvPicPr>
             <a:picLocks noChangeAspect="1"/>
           </p:cNvPicPr>
@@ -13264,7 +13363,7 @@
       </p:pic>
       <p:sp>
         <p:nvSpPr>
-          <p:cNvPr id="9" name="text-231"/>
+          <p:cNvPr id="9" name="text-238"/>
           <p:cNvSpPr txBox="1"/>
           <p:nvPr/>
         </p:nvSpPr>
@@ -13460,7 +13559,7 @@
       </p:sp>
       <p:sp>
         <p:nvSpPr>
-          <p:cNvPr id="5" name="text-232"/>
+          <p:cNvPr id="5" name="text-239"/>
           <p:cNvSpPr txBox="1"/>
           <p:nvPr/>
         </p:nvSpPr>
@@ -13496,7 +13595,7 @@
       </p:sp>
       <p:sp>
         <p:nvSpPr>
-          <p:cNvPr id="6" name="text-233"/>
+          <p:cNvPr id="6" name="text-240"/>
           <p:cNvSpPr txBox="1"/>
           <p:nvPr/>
         </p:nvSpPr>
@@ -13532,7 +13631,7 @@
       </p:sp>
       <p:sp>
         <p:nvSpPr>
-          <p:cNvPr id="7" name="text-234"/>
+          <p:cNvPr id="7" name="text-241"/>
           <p:cNvSpPr txBox="1"/>
           <p:nvPr/>
         </p:nvSpPr>
@@ -13620,7 +13719,7 @@
       </p:sp>
       <p:sp>
         <p:nvSpPr>
-          <p:cNvPr id="10" name="text-235"/>
+          <p:cNvPr id="10" name="text-242"/>
           <p:cNvSpPr txBox="1"/>
           <p:nvPr/>
         </p:nvSpPr>
@@ -13656,7 +13755,7 @@
       </p:sp>
       <p:sp>
         <p:nvSpPr>
-          <p:cNvPr id="11" name="text-236"/>
+          <p:cNvPr id="11" name="text-243"/>
           <p:cNvSpPr txBox="1"/>
           <p:nvPr/>
         </p:nvSpPr>
@@ -13692,7 +13791,7 @@
       </p:sp>
       <p:sp>
         <p:nvSpPr>
-          <p:cNvPr id="12" name="text-237"/>
+          <p:cNvPr id="12" name="text-244"/>
           <p:cNvSpPr txBox="1"/>
           <p:nvPr/>
         </p:nvSpPr>
@@ -13780,7 +13879,7 @@
       </p:sp>
       <p:sp>
         <p:nvSpPr>
-          <p:cNvPr id="15" name="text-238"/>
+          <p:cNvPr id="15" name="text-245"/>
           <p:cNvSpPr txBox="1"/>
           <p:nvPr/>
         </p:nvSpPr>
@@ -13816,7 +13915,7 @@
       </p:sp>
       <p:sp>
         <p:nvSpPr>
-          <p:cNvPr id="16" name="text-239"/>
+          <p:cNvPr id="16" name="text-246"/>
           <p:cNvSpPr txBox="1"/>
           <p:nvPr/>
         </p:nvSpPr>
@@ -13852,7 +13951,7 @@
       </p:sp>
       <p:sp>
         <p:nvSpPr>
-          <p:cNvPr id="17" name="text-240"/>
+          <p:cNvPr id="17" name="text-247"/>
           <p:cNvSpPr txBox="1"/>
           <p:nvPr/>
         </p:nvSpPr>
@@ -13940,7 +14039,7 @@
       </p:sp>
       <p:sp>
         <p:nvSpPr>
-          <p:cNvPr id="20" name="text-241"/>
+          <p:cNvPr id="20" name="text-248"/>
           <p:cNvSpPr txBox="1"/>
           <p:nvPr/>
         </p:nvSpPr>
@@ -13976,7 +14075,7 @@
       </p:sp>
       <p:sp>
         <p:nvSpPr>
-          <p:cNvPr id="21" name="text-242"/>
+          <p:cNvPr id="21" name="text-249"/>
           <p:cNvSpPr txBox="1"/>
           <p:nvPr/>
         </p:nvSpPr>
@@ -14012,7 +14111,7 @@
       </p:sp>
       <p:sp>
         <p:nvSpPr>
-          <p:cNvPr id="22" name="text-243"/>
+          <p:cNvPr id="22" name="text-250"/>
           <p:cNvSpPr txBox="1"/>
           <p:nvPr/>
         </p:nvSpPr>
@@ -14100,7 +14199,7 @@
       </p:sp>
       <p:sp>
         <p:nvSpPr>
-          <p:cNvPr id="25" name="text-244"/>
+          <p:cNvPr id="25" name="text-251"/>
           <p:cNvSpPr txBox="1"/>
           <p:nvPr/>
         </p:nvSpPr>
@@ -14136,7 +14235,7 @@
       </p:sp>
       <p:sp>
         <p:nvSpPr>
-          <p:cNvPr id="26" name="text-245"/>
+          <p:cNvPr id="26" name="text-252"/>
           <p:cNvSpPr txBox="1"/>
           <p:nvPr/>
         </p:nvSpPr>
@@ -14172,7 +14271,7 @@
       </p:sp>
       <p:sp>
         <p:nvSpPr>
-          <p:cNvPr id="27" name="text-246"/>
+          <p:cNvPr id="27" name="text-253"/>
           <p:cNvSpPr txBox="1"/>
           <p:nvPr/>
         </p:nvSpPr>
@@ -14260,7 +14359,7 @@
       </p:sp>
       <p:sp>
         <p:nvSpPr>
-          <p:cNvPr id="30" name="text-247"/>
+          <p:cNvPr id="30" name="text-254"/>
           <p:cNvSpPr txBox="1"/>
           <p:nvPr/>
         </p:nvSpPr>
@@ -14296,7 +14395,7 @@
       </p:sp>
       <p:sp>
         <p:nvSpPr>
-          <p:cNvPr id="31" name="text-248"/>
+          <p:cNvPr id="31" name="text-255"/>
           <p:cNvSpPr txBox="1"/>
           <p:nvPr/>
         </p:nvSpPr>
@@ -14332,7 +14431,7 @@
       </p:sp>
       <p:sp>
         <p:nvSpPr>
-          <p:cNvPr id="32" name="text-249"/>
+          <p:cNvPr id="32" name="text-256"/>
           <p:cNvSpPr txBox="1"/>
           <p:nvPr/>
         </p:nvSpPr>
@@ -14503,7 +14602,7 @@
       </p:sp>
       <p:sp>
         <p:nvSpPr>
-          <p:cNvPr id="4" name="text-250"/>
+          <p:cNvPr id="4" name="text-257"/>
           <p:cNvSpPr txBox="1"/>
           <p:nvPr/>
         </p:nvSpPr>
@@ -14539,7 +14638,7 @@
       </p:sp>
       <p:sp>
         <p:nvSpPr>
-          <p:cNvPr id="5" name="text-251"/>
+          <p:cNvPr id="5" name="text-258"/>
           <p:cNvSpPr txBox="1"/>
           <p:nvPr/>
         </p:nvSpPr>
@@ -14602,7 +14701,7 @@
       </p:sp>
       <p:sp>
         <p:nvSpPr>
-          <p:cNvPr id="7" name="text-252"/>
+          <p:cNvPr id="7" name="text-259"/>
           <p:cNvSpPr txBox="1"/>
           <p:nvPr/>
         </p:nvSpPr>
@@ -14638,7 +14737,7 @@
       </p:sp>
       <p:sp>
         <p:nvSpPr>
-          <p:cNvPr id="8" name="text-253"/>
+          <p:cNvPr id="8" name="text-260"/>
           <p:cNvSpPr txBox="1"/>
           <p:nvPr/>
         </p:nvSpPr>
@@ -14701,7 +14800,7 @@
       </p:sp>
       <p:sp>
         <p:nvSpPr>
-          <p:cNvPr id="10" name="text-254"/>
+          <p:cNvPr id="10" name="text-261"/>
           <p:cNvSpPr txBox="1"/>
           <p:nvPr/>
         </p:nvSpPr>
@@ -14737,7 +14836,7 @@
       </p:sp>
       <p:sp>
         <p:nvSpPr>
-          <p:cNvPr id="11" name="text-255"/>
+          <p:cNvPr id="11" name="text-262"/>
           <p:cNvSpPr txBox="1"/>
           <p:nvPr/>
         </p:nvSpPr>
@@ -14800,7 +14899,7 @@
       </p:sp>
       <p:sp>
         <p:nvSpPr>
-          <p:cNvPr id="13" name="text-256"/>
+          <p:cNvPr id="13" name="text-263"/>
           <p:cNvSpPr txBox="1"/>
           <p:nvPr/>
         </p:nvSpPr>
@@ -14828,7 +14927,7 @@
                   <a:schemeClr val="tx1"/>
                 </a:solidFill>
               </a:rPr>
-              <a:t>A snapshot of 250 films</a:t>
+              <a:t>Snapshot data, plain-string characters</a:t>
             </a:r>
             <a:endParaRPr lang="en-US" sz="1800" dirty="0"/>
           </a:p>
@@ -14836,7 +14935,7 @@
       </p:sp>
       <p:sp>
         <p:nvSpPr>
-          <p:cNvPr id="14" name="text-257"/>
+          <p:cNvPr id="14" name="text-264"/>
           <p:cNvSpPr txBox="1"/>
           <p:nvPr/>
         </p:nvSpPr>
@@ -14864,7 +14963,7 @@
                   <a:schemeClr val="accent4"/>
                 </a:solidFill>
               </a:rPr>
-              <a:t>Links are unique-id matches only: 2 ambiguous resources stay unlinked. More films and awards are the obvious extension.</a:t>
+              <a:t>250 films; one film and one actor stay unlinked as ambiguous. characterName is a plain string, so one name can mean different characters (query 18).</a:t>
             </a:r>
             <a:endParaRPr lang="en-US" sz="1400" dirty="0"/>
           </a:p>
@@ -15797,7 +15896,7 @@
       </p:pic>
       <p:pic>
         <p:nvPicPr>
-          <p:cNvPr id="4" name="star-258" descr="preencoded.png">    </p:cNvPr>
+          <p:cNvPr id="4" name="star-265" descr="preencoded.png">    </p:cNvPr>
           <p:cNvPicPr>
             <a:picLocks noChangeAspect="1"/>
           </p:cNvPicPr>
@@ -15821,7 +15920,7 @@
       </p:pic>
       <p:pic>
         <p:nvPicPr>
-          <p:cNvPr id="5" name="star-259" descr="preencoded.png">    </p:cNvPr>
+          <p:cNvPr id="5" name="star-266" descr="preencoded.png">    </p:cNvPr>
           <p:cNvPicPr>
             <a:picLocks noChangeAspect="1"/>
           </p:cNvPicPr>
@@ -15845,7 +15944,7 @@
       </p:pic>
       <p:pic>
         <p:nvPicPr>
-          <p:cNvPr id="6" name="star-260" descr="preencoded.png">    </p:cNvPr>
+          <p:cNvPr id="6" name="star-267" descr="preencoded.png">    </p:cNvPr>
           <p:cNvPicPr>
             <a:picLocks noChangeAspect="1"/>
           </p:cNvPicPr>
@@ -15869,7 +15968,7 @@
       </p:pic>
       <p:pic>
         <p:nvPicPr>
-          <p:cNvPr id="7" name="star-261" descr="preencoded.png">    </p:cNvPr>
+          <p:cNvPr id="7" name="star-268" descr="preencoded.png">    </p:cNvPr>
           <p:cNvPicPr>
             <a:picLocks noChangeAspect="1"/>
           </p:cNvPicPr>
@@ -15893,7 +15992,7 @@
       </p:pic>
       <p:pic>
         <p:nvPicPr>
-          <p:cNvPr id="8" name="star-262" descr="preencoded.png">    </p:cNvPr>
+          <p:cNvPr id="8" name="star-269" descr="preencoded.png">    </p:cNvPr>
           <p:cNvPicPr>
             <a:picLocks noChangeAspect="1"/>
           </p:cNvPicPr>
@@ -15993,7 +16092,7 @@
       </p:sp>
       <p:sp>
         <p:nvSpPr>
-          <p:cNvPr id="11" name="text-263"/>
+          <p:cNvPr id="11" name="text-270"/>
           <p:cNvSpPr txBox="1"/>
           <p:nvPr/>
         </p:nvSpPr>
@@ -16350,7 +16449,7 @@
                   <a:schemeClr val="accent4"/>
                 </a:solidFill>
               </a:rPr>
-              <a:t>7 core classes, reused vocabularies, defined classes the reasoner can fill</a:t>
+              <a:t>Core classes, an n-ary CastRole, reused vocabularies, defined classes the reasoner can fill</a:t>
             </a:r>
             <a:endParaRPr lang="en-US" sz="1400" dirty="0"/>
           </a:p>
@@ -17386,7 +17485,7 @@
                   <a:schemeClr val="accent4"/>
                 </a:solidFill>
               </a:rPr>
-              <a:t>Terminal interface and Protégé, 15 queries including federated ones</a:t>
+              <a:t>Terminal interface and Protégé, 21 queries: local, cast-role and federated</a:t>
             </a:r>
             <a:endParaRPr lang="en-US" sz="1400" dirty="0"/>
           </a:p>
@@ -19259,7 +19358,7 @@
                   <a:schemeClr val="tx1"/>
                 </a:solidFill>
               </a:rPr>
-              <a:t>Ontology: seven classes, mostly reused vocabulary</a:t>
+              <a:t>Ontology: core classes, mostly reused vocabulary</a:t>
             </a:r>
             <a:endParaRPr lang="en-US" sz="3200" dirty="0"/>
           </a:p>
@@ -19533,8 +19632,8 @@
         </p:nvSpPr>
         <p:spPr>
           <a:xfrm>
-            <a:off x="5120640" y="3867912"/>
-            <a:ext cx="0" cy="1362456"/>
+            <a:off x="5446838" y="3867912"/>
+            <a:ext cx="1536565" cy="1636776"/>
           </a:xfrm>
           <a:prstGeom prst="line">
             <a:avLst/>
@@ -19557,7 +19656,7 @@
         </p:nvSpPr>
         <p:spPr>
           <a:xfrm>
-            <a:off x="4572000" y="4421124"/>
+            <a:off x="5757921" y="4558284"/>
             <a:ext cx="1097280" cy="256032"/>
           </a:xfrm>
           <a:prstGeom prst="rect">
@@ -19598,8 +19697,8 @@
         </p:nvSpPr>
         <p:spPr>
           <a:xfrm>
-            <a:off x="5641848" y="3867912"/>
-            <a:ext cx="1357884" cy="905256"/>
+            <a:off x="5120640" y="3867912"/>
+            <a:ext cx="0" cy="1636776"/>
           </a:xfrm>
           <a:prstGeom prst="line">
             <a:avLst/>
@@ -19622,7 +19721,7 @@
         </p:nvSpPr>
         <p:spPr>
           <a:xfrm>
-            <a:off x="5772150" y="4192524"/>
+            <a:off x="4572000" y="4558284"/>
             <a:ext cx="1097280" cy="256032"/>
           </a:xfrm>
           <a:prstGeom prst="rect">
@@ -19649,6 +19748,136 @@
                 <a:ea typeface="Courier New" pitchFamily="34" charset="-122"/>
                 <a:cs typeface="Courier New" pitchFamily="34" charset="-120"/>
               </a:rPr>
+              <a:t>hasCastRole</a:t>
+            </a:r>
+            <a:endParaRPr lang="en-US" sz="1100" dirty="0"/>
+          </a:p>
+        </p:txBody>
+      </p:sp>
+      <p:sp>
+        <p:nvSpPr>
+          <p:cNvPr id="15" name="edge-105"/>
+          <p:cNvSpPr/>
+          <p:nvPr/>
+        </p:nvSpPr>
+        <p:spPr>
+          <a:xfrm flipH="1" flipV="1">
+            <a:off x="3849226" y="5010912"/>
+            <a:ext cx="837272" cy="493776"/>
+          </a:xfrm>
+          <a:prstGeom prst="line">
+            <a:avLst/>
+          </a:prstGeom>
+          <a:noFill/>
+          <a:ln w="19050">
+            <a:solidFill>
+              <a:srgbClr val="1F2329"/>
+            </a:solidFill>
+            <a:prstDash val="solid"/>
+            <a:tailEnd type="triangle"/>
+          </a:ln>
+        </p:spPr>
+      </p:sp>
+      <p:sp>
+        <p:nvSpPr>
+          <p:cNvPr id="16" name="text-106"/>
+          <p:cNvSpPr txBox="1"/>
+          <p:nvPr/>
+        </p:nvSpPr>
+        <p:spPr>
+          <a:xfrm>
+            <a:off x="3033423" y="5239512"/>
+            <a:ext cx="1097280" cy="256032"/>
+          </a:xfrm>
+          <a:prstGeom prst="rect">
+            <a:avLst/>
+          </a:prstGeom>
+          <a:solidFill>
+            <a:schemeClr val="bg1"/>
+          </a:solidFill>
+          <a:ln/>
+        </p:spPr>
+        <p:txBody>
+          <a:bodyPr wrap="square" lIns="0" tIns="0" rIns="0" bIns="0" rtlCol="0" anchor="ctr"/>
+          <a:lstStyle/>
+          <a:p>
+            <a:pPr algn="ctr" indent="0" marL="0">
+              <a:buNone/>
+            </a:pPr>
+            <a:r>
+              <a:rPr lang="en-US" sz="1100" dirty="0">
+                <a:solidFill>
+                  <a:schemeClr val="accent4"/>
+                </a:solidFill>
+                <a:latin typeface="Courier New" pitchFamily="34" charset="0"/>
+                <a:ea typeface="Courier New" pitchFamily="34" charset="-122"/>
+                <a:cs typeface="Courier New" pitchFamily="34" charset="-120"/>
+              </a:rPr>
+              <a:t>playedBy</a:t>
+            </a:r>
+            <a:endParaRPr lang="en-US" sz="1100" dirty="0"/>
+          </a:p>
+        </p:txBody>
+      </p:sp>
+      <p:sp>
+        <p:nvSpPr>
+          <p:cNvPr id="17" name="edge-107"/>
+          <p:cNvSpPr/>
+          <p:nvPr/>
+        </p:nvSpPr>
+        <p:spPr>
+          <a:xfrm>
+            <a:off x="5641848" y="3867912"/>
+            <a:ext cx="1357884" cy="905256"/>
+          </a:xfrm>
+          <a:prstGeom prst="line">
+            <a:avLst/>
+          </a:prstGeom>
+          <a:noFill/>
+          <a:ln w="19050">
+            <a:solidFill>
+              <a:srgbClr val="1F2329"/>
+            </a:solidFill>
+            <a:prstDash val="solid"/>
+            <a:tailEnd type="triangle"/>
+          </a:ln>
+        </p:spPr>
+      </p:sp>
+      <p:sp>
+        <p:nvSpPr>
+          <p:cNvPr id="18" name="text-108"/>
+          <p:cNvSpPr txBox="1"/>
+          <p:nvPr/>
+        </p:nvSpPr>
+        <p:spPr>
+          <a:xfrm>
+            <a:off x="5772150" y="4192524"/>
+            <a:ext cx="1097280" cy="256032"/>
+          </a:xfrm>
+          <a:prstGeom prst="rect">
+            <a:avLst/>
+          </a:prstGeom>
+          <a:solidFill>
+            <a:schemeClr val="bg1"/>
+          </a:solidFill>
+          <a:ln/>
+        </p:spPr>
+        <p:txBody>
+          <a:bodyPr wrap="square" lIns="0" tIns="0" rIns="0" bIns="0" rtlCol="0" anchor="ctr"/>
+          <a:lstStyle/>
+          <a:p>
+            <a:pPr algn="ctr" indent="0" marL="0">
+              <a:buNone/>
+            </a:pPr>
+            <a:r>
+              <a:rPr lang="en-US" sz="1100" dirty="0">
+                <a:solidFill>
+                  <a:schemeClr val="accent4"/>
+                </a:solidFill>
+                <a:latin typeface="Courier New" pitchFamily="34" charset="0"/>
+                <a:ea typeface="Courier New" pitchFamily="34" charset="-122"/>
+                <a:cs typeface="Courier New" pitchFamily="34" charset="-120"/>
+              </a:rPr>
               <a:t>producedIn</a:t>
             </a:r>
             <a:endParaRPr lang="en-US" sz="1100" dirty="0"/>
@@ -19657,7 +19886,7 @@
       </p:sp>
       <p:sp>
         <p:nvSpPr>
-          <p:cNvPr id="15" name="edge-105"/>
+          <p:cNvPr id="19" name="edge-109"/>
           <p:cNvSpPr/>
           <p:nvPr/>
         </p:nvSpPr>
@@ -19681,7 +19910,7 @@
       </p:sp>
       <p:sp>
         <p:nvSpPr>
-          <p:cNvPr id="16" name="text-106"/>
+          <p:cNvPr id="20" name="text-110"/>
           <p:cNvSpPr txBox="1"/>
           <p:nvPr/>
         </p:nvSpPr>
@@ -19722,7 +19951,7 @@
       </p:sp>
       <p:sp>
         <p:nvSpPr>
-          <p:cNvPr id="17" name="edge-107"/>
+          <p:cNvPr id="21" name="edge-111"/>
           <p:cNvSpPr/>
           <p:nvPr/>
         </p:nvSpPr>
@@ -19746,7 +19975,7 @@
       </p:sp>
       <p:sp>
         <p:nvSpPr>
-          <p:cNvPr id="18" name="text-108"/>
+          <p:cNvPr id="22" name="text-112"/>
           <p:cNvSpPr txBox="1"/>
           <p:nvPr/>
         </p:nvSpPr>
@@ -19787,7 +20016,7 @@
       </p:sp>
       <p:sp>
         <p:nvSpPr>
-          <p:cNvPr id="19" name="edge-109"/>
+          <p:cNvPr id="23" name="edge-113"/>
           <p:cNvSpPr/>
           <p:nvPr/>
         </p:nvSpPr>
@@ -19811,7 +20040,7 @@
       </p:sp>
       <p:sp>
         <p:nvSpPr>
-          <p:cNvPr id="20" name="text-110"/>
+          <p:cNvPr id="24" name="text-114"/>
           <p:cNvSpPr txBox="1"/>
           <p:nvPr/>
         </p:nvSpPr>
@@ -19852,7 +20081,7 @@
       </p:sp>
       <p:sp>
         <p:nvSpPr>
-          <p:cNvPr id="21" name="node-Award"/>
+          <p:cNvPr id="25" name="node-Award"/>
           <p:cNvSpPr/>
           <p:nvPr/>
         </p:nvSpPr>
@@ -19879,7 +20108,7 @@
       </p:sp>
       <p:sp>
         <p:nvSpPr>
-          <p:cNvPr id="22" name="text-111"/>
+          <p:cNvPr id="26" name="text-115"/>
           <p:cNvSpPr txBox="1"/>
           <p:nvPr/>
         </p:nvSpPr>
@@ -19915,7 +20144,7 @@
       </p:sp>
       <p:sp>
         <p:nvSpPr>
-          <p:cNvPr id="23" name="node-Person"/>
+          <p:cNvPr id="27" name="node-Person"/>
           <p:cNvSpPr/>
           <p:nvPr/>
         </p:nvSpPr>
@@ -19942,7 +20171,7 @@
       </p:sp>
       <p:sp>
         <p:nvSpPr>
-          <p:cNvPr id="24" name="text-112"/>
+          <p:cNvPr id="28" name="text-116"/>
           <p:cNvSpPr txBox="1"/>
           <p:nvPr/>
         </p:nvSpPr>
@@ -19978,7 +20207,7 @@
       </p:sp>
       <p:sp>
         <p:nvSpPr>
-          <p:cNvPr id="25" name="node-Director"/>
+          <p:cNvPr id="29" name="node-Director"/>
           <p:cNvSpPr/>
           <p:nvPr/>
         </p:nvSpPr>
@@ -20005,7 +20234,7 @@
       </p:sp>
       <p:sp>
         <p:nvSpPr>
-          <p:cNvPr id="26" name="text-113"/>
+          <p:cNvPr id="30" name="text-117"/>
           <p:cNvSpPr txBox="1"/>
           <p:nvPr/>
         </p:nvSpPr>
@@ -20041,7 +20270,7 @@
       </p:sp>
       <p:sp>
         <p:nvSpPr>
-          <p:cNvPr id="27" name="node-Actor"/>
+          <p:cNvPr id="31" name="node-Actor"/>
           <p:cNvSpPr/>
           <p:nvPr/>
         </p:nvSpPr>
@@ -20068,7 +20297,7 @@
       </p:sp>
       <p:sp>
         <p:nvSpPr>
-          <p:cNvPr id="28" name="text-114"/>
+          <p:cNvPr id="32" name="text-118"/>
           <p:cNvSpPr txBox="1"/>
           <p:nvPr/>
         </p:nvSpPr>
@@ -20104,7 +20333,7 @@
       </p:sp>
       <p:sp>
         <p:nvSpPr>
-          <p:cNvPr id="29" name="node-Movie"/>
+          <p:cNvPr id="33" name="node-Movie"/>
           <p:cNvSpPr/>
           <p:nvPr/>
         </p:nvSpPr>
@@ -20131,7 +20360,7 @@
       </p:sp>
       <p:sp>
         <p:nvSpPr>
-          <p:cNvPr id="30" name="text-115"/>
+          <p:cNvPr id="34" name="text-119"/>
           <p:cNvSpPr txBox="1"/>
           <p:nvPr/>
         </p:nvSpPr>
@@ -20167,18 +20396,18 @@
       </p:sp>
       <p:sp>
         <p:nvSpPr>
-          <p:cNvPr id="31" name="node-Links"/>
+          <p:cNvPr id="35" name="node-Links"/>
           <p:cNvSpPr/>
           <p:nvPr/>
         </p:nvSpPr>
         <p:spPr>
           <a:xfrm>
-            <a:off x="4069080" y="5257800"/>
-            <a:ext cx="2103120" cy="548640"/>
+            <a:off x="6263640" y="5532120"/>
+            <a:ext cx="1920240" cy="457200"/>
           </a:xfrm>
           <a:prstGeom prst="roundRect">
             <a:avLst>
-              <a:gd name="adj" fmla="val 20000"/>
+              <a:gd name="adj" fmla="val 24000"/>
             </a:avLst>
           </a:prstGeom>
           <a:solidFill>
@@ -20194,14 +20423,14 @@
       </p:sp>
       <p:sp>
         <p:nvSpPr>
-          <p:cNvPr id="32" name="text-116"/>
+          <p:cNvPr id="36" name="text-120"/>
           <p:cNvSpPr txBox="1"/>
           <p:nvPr/>
         </p:nvSpPr>
         <p:spPr>
           <a:xfrm>
-            <a:off x="4069080" y="5257800"/>
-            <a:ext cx="2103120" cy="548640"/>
+            <a:off x="6263640" y="5532120"/>
+            <a:ext cx="1920240" cy="457200"/>
           </a:xfrm>
           <a:prstGeom prst="rect">
             <a:avLst/>
@@ -20230,18 +20459,18 @@
       </p:sp>
       <p:sp>
         <p:nvSpPr>
-          <p:cNvPr id="33" name="node-Genre"/>
+          <p:cNvPr id="37" name="node-CastRole"/>
           <p:cNvSpPr/>
           <p:nvPr/>
         </p:nvSpPr>
         <p:spPr>
           <a:xfrm>
-            <a:off x="6766560" y="1691640"/>
-            <a:ext cx="1371600" cy="548640"/>
+            <a:off x="4434840" y="5532120"/>
+            <a:ext cx="1371600" cy="457200"/>
           </a:xfrm>
           <a:prstGeom prst="roundRect">
             <a:avLst>
-              <a:gd name="adj" fmla="val 20000"/>
+              <a:gd name="adj" fmla="val 24000"/>
             </a:avLst>
           </a:prstGeom>
           <a:solidFill>
@@ -20257,50 +20486,50 @@
       </p:sp>
       <p:sp>
         <p:nvSpPr>
-          <p:cNvPr id="34" name="text-117"/>
+          <p:cNvPr id="38" name="text-121"/>
           <p:cNvSpPr txBox="1"/>
+          <p:nvPr/>
+        </p:nvSpPr>
+        <p:spPr>
+          <a:xfrm>
+            <a:off x="4434840" y="5532120"/>
+            <a:ext cx="1371600" cy="457200"/>
+          </a:xfrm>
+          <a:prstGeom prst="rect">
+            <a:avLst/>
+          </a:prstGeom>
+          <a:noFill/>
+          <a:ln/>
+        </p:spPr>
+        <p:txBody>
+          <a:bodyPr wrap="square" lIns="0" tIns="0" rIns="0" bIns="0" rtlCol="0" anchor="ctr"/>
+          <a:lstStyle/>
+          <a:p>
+            <a:pPr algn="ctr" indent="0" marL="0">
+              <a:buNone/>
+            </a:pPr>
+            <a:r>
+              <a:rPr lang="en-US" sz="1500" b="1" dirty="0">
+                <a:solidFill>
+                  <a:schemeClr val="tx1"/>
+                </a:solidFill>
+              </a:rPr>
+              <a:t>CastRole</a:t>
+            </a:r>
+            <a:endParaRPr lang="en-US" sz="1500" dirty="0"/>
+          </a:p>
+        </p:txBody>
+      </p:sp>
+      <p:sp>
+        <p:nvSpPr>
+          <p:cNvPr id="39" name="node-Genre"/>
+          <p:cNvSpPr/>
           <p:nvPr/>
         </p:nvSpPr>
         <p:spPr>
           <a:xfrm>
             <a:off x="6766560" y="1691640"/>
             <a:ext cx="1371600" cy="548640"/>
-          </a:xfrm>
-          <a:prstGeom prst="rect">
-            <a:avLst/>
-          </a:prstGeom>
-          <a:noFill/>
-          <a:ln/>
-        </p:spPr>
-        <p:txBody>
-          <a:bodyPr wrap="square" lIns="0" tIns="0" rIns="0" bIns="0" rtlCol="0" anchor="ctr"/>
-          <a:lstStyle/>
-          <a:p>
-            <a:pPr algn="ctr" indent="0" marL="0">
-              <a:buNone/>
-            </a:pPr>
-            <a:r>
-              <a:rPr lang="en-US" sz="1500" b="1" dirty="0">
-                <a:solidFill>
-                  <a:schemeClr val="tx1"/>
-                </a:solidFill>
-              </a:rPr>
-              <a:t>Genre</a:t>
-            </a:r>
-            <a:endParaRPr lang="en-US" sz="1500" dirty="0"/>
-          </a:p>
-        </p:txBody>
-      </p:sp>
-      <p:sp>
-        <p:nvSpPr>
-          <p:cNvPr id="35" name="node-Studio"/>
-          <p:cNvSpPr/>
-          <p:nvPr/>
-        </p:nvSpPr>
-        <p:spPr>
-          <a:xfrm>
-            <a:off x="6949440" y="3246120"/>
-            <a:ext cx="1280160" cy="548640"/>
           </a:xfrm>
           <a:prstGeom prst="roundRect">
             <a:avLst>
@@ -20320,50 +20549,50 @@
       </p:sp>
       <p:sp>
         <p:nvSpPr>
-          <p:cNvPr id="36" name="text-118"/>
+          <p:cNvPr id="40" name="text-122"/>
           <p:cNvSpPr txBox="1"/>
+          <p:nvPr/>
+        </p:nvSpPr>
+        <p:spPr>
+          <a:xfrm>
+            <a:off x="6766560" y="1691640"/>
+            <a:ext cx="1371600" cy="548640"/>
+          </a:xfrm>
+          <a:prstGeom prst="rect">
+            <a:avLst/>
+          </a:prstGeom>
+          <a:noFill/>
+          <a:ln/>
+        </p:spPr>
+        <p:txBody>
+          <a:bodyPr wrap="square" lIns="0" tIns="0" rIns="0" bIns="0" rtlCol="0" anchor="ctr"/>
+          <a:lstStyle/>
+          <a:p>
+            <a:pPr algn="ctr" indent="0" marL="0">
+              <a:buNone/>
+            </a:pPr>
+            <a:r>
+              <a:rPr lang="en-US" sz="1500" b="1" dirty="0">
+                <a:solidFill>
+                  <a:schemeClr val="tx1"/>
+                </a:solidFill>
+              </a:rPr>
+              <a:t>Genre</a:t>
+            </a:r>
+            <a:endParaRPr lang="en-US" sz="1500" dirty="0"/>
+          </a:p>
+        </p:txBody>
+      </p:sp>
+      <p:sp>
+        <p:nvSpPr>
+          <p:cNvPr id="41" name="node-Studio"/>
+          <p:cNvSpPr/>
           <p:nvPr/>
         </p:nvSpPr>
         <p:spPr>
           <a:xfrm>
             <a:off x="6949440" y="3246120"/>
             <a:ext cx="1280160" cy="548640"/>
-          </a:xfrm>
-          <a:prstGeom prst="rect">
-            <a:avLst/>
-          </a:prstGeom>
-          <a:noFill/>
-          <a:ln/>
-        </p:spPr>
-        <p:txBody>
-          <a:bodyPr wrap="square" lIns="0" tIns="0" rIns="0" bIns="0" rtlCol="0" anchor="ctr"/>
-          <a:lstStyle/>
-          <a:p>
-            <a:pPr algn="ctr" indent="0" marL="0">
-              <a:buNone/>
-            </a:pPr>
-            <a:r>
-              <a:rPr lang="en-US" sz="1500" b="1" dirty="0">
-                <a:solidFill>
-                  <a:schemeClr val="tx1"/>
-                </a:solidFill>
-              </a:rPr>
-              <a:t>Studio</a:t>
-            </a:r>
-            <a:endParaRPr lang="en-US" sz="1500" dirty="0"/>
-          </a:p>
-        </p:txBody>
-      </p:sp>
-      <p:sp>
-        <p:nvSpPr>
-          <p:cNvPr id="37" name="node-Country"/>
-          <p:cNvSpPr/>
-          <p:nvPr/>
-        </p:nvSpPr>
-        <p:spPr>
-          <a:xfrm>
-            <a:off x="6766560" y="4800600"/>
-            <a:ext cx="1371600" cy="548640"/>
           </a:xfrm>
           <a:prstGeom prst="roundRect">
             <a:avLst>
@@ -20383,8 +20612,44 @@
       </p:sp>
       <p:sp>
         <p:nvSpPr>
-          <p:cNvPr id="38" name="text-119"/>
+          <p:cNvPr id="42" name="text-123"/>
           <p:cNvSpPr txBox="1"/>
+          <p:nvPr/>
+        </p:nvSpPr>
+        <p:spPr>
+          <a:xfrm>
+            <a:off x="6949440" y="3246120"/>
+            <a:ext cx="1280160" cy="548640"/>
+          </a:xfrm>
+          <a:prstGeom prst="rect">
+            <a:avLst/>
+          </a:prstGeom>
+          <a:noFill/>
+          <a:ln/>
+        </p:spPr>
+        <p:txBody>
+          <a:bodyPr wrap="square" lIns="0" tIns="0" rIns="0" bIns="0" rtlCol="0" anchor="ctr"/>
+          <a:lstStyle/>
+          <a:p>
+            <a:pPr algn="ctr" indent="0" marL="0">
+              <a:buNone/>
+            </a:pPr>
+            <a:r>
+              <a:rPr lang="en-US" sz="1500" b="1" dirty="0">
+                <a:solidFill>
+                  <a:schemeClr val="tx1"/>
+                </a:solidFill>
+              </a:rPr>
+              <a:t>Studio</a:t>
+            </a:r>
+            <a:endParaRPr lang="en-US" sz="1500" dirty="0"/>
+          </a:p>
+        </p:txBody>
+      </p:sp>
+      <p:sp>
+        <p:nvSpPr>
+          <p:cNvPr id="43" name="node-Country"/>
+          <p:cNvSpPr/>
           <p:nvPr/>
         </p:nvSpPr>
         <p:spPr>
@@ -20392,6 +20657,33 @@
             <a:off x="6766560" y="4800600"/>
             <a:ext cx="1371600" cy="548640"/>
           </a:xfrm>
+          <a:prstGeom prst="roundRect">
+            <a:avLst>
+              <a:gd name="adj" fmla="val 20000"/>
+            </a:avLst>
+          </a:prstGeom>
+          <a:solidFill>
+            <a:schemeClr val="bg1"/>
+          </a:solidFill>
+          <a:ln w="19050">
+            <a:solidFill>
+              <a:srgbClr val="BF1E2E"/>
+            </a:solidFill>
+            <a:prstDash val="solid"/>
+          </a:ln>
+        </p:spPr>
+      </p:sp>
+      <p:sp>
+        <p:nvSpPr>
+          <p:cNvPr id="44" name="text-124"/>
+          <p:cNvSpPr txBox="1"/>
+          <p:nvPr/>
+        </p:nvSpPr>
+        <p:spPr>
+          <a:xfrm>
+            <a:off x="6766560" y="4800600"/>
+            <a:ext cx="1371600" cy="548640"/>
+          </a:xfrm>
           <a:prstGeom prst="rect">
             <a:avLst/>
           </a:prstGeom>
@@ -20419,7 +20711,7 @@
       </p:sp>
       <p:sp>
         <p:nvSpPr>
-          <p:cNvPr id="39" name="vocab-card"/>
+          <p:cNvPr id="45" name="vocab-card"/>
           <p:cNvSpPr/>
           <p:nvPr/>
         </p:nvSpPr>
@@ -20446,7 +20738,7 @@
       </p:sp>
       <p:sp>
         <p:nvSpPr>
-          <p:cNvPr id="40" name="text-120"/>
+          <p:cNvPr id="46" name="text-125"/>
           <p:cNvSpPr txBox="1"/>
           <p:nvPr/>
         </p:nvSpPr>
@@ -20482,7 +20774,7 @@
       </p:sp>
       <p:sp>
         <p:nvSpPr>
-          <p:cNvPr id="41" name="text-121"/>
+          <p:cNvPr id="47" name="text-126"/>
           <p:cNvSpPr txBox="1"/>
           <p:nvPr/>
         </p:nvSpPr>
@@ -20558,13 +20850,13 @@
       </p:sp>
       <p:sp>
         <p:nvSpPr>
-          <p:cNvPr id="42" name="text-122"/>
+          <p:cNvPr id="48" name="text-127"/>
           <p:cNvSpPr txBox="1"/>
           <p:nvPr/>
         </p:nvSpPr>
         <p:spPr>
           <a:xfrm>
-            <a:off x="8823960" y="3520440"/>
+            <a:off x="8823960" y="3291840"/>
             <a:ext cx="2651760" cy="365760"/>
           </a:xfrm>
           <a:prstGeom prst="rect">
@@ -20594,14 +20886,14 @@
       </p:sp>
       <p:sp>
         <p:nvSpPr>
-          <p:cNvPr id="43" name="text-123"/>
+          <p:cNvPr id="49" name="text-128"/>
           <p:cNvSpPr txBox="1"/>
           <p:nvPr/>
         </p:nvSpPr>
         <p:spPr>
           <a:xfrm>
-            <a:off x="8823960" y="3931920"/>
-            <a:ext cx="2651760" cy="1188720"/>
+            <a:off x="8823960" y="3703320"/>
+            <a:ext cx="2651760" cy="1920240"/>
           </a:xfrm>
           <a:prstGeom prst="rect">
             <a:avLst/>
@@ -20663,6 +20955,24 @@
                 </a:solidFill>
               </a:rPr>
               <a:t>Genre, Studio, Country, Award</a:t>
+            </a:r>
+            <a:endParaRPr lang="en-US" sz="1400" dirty="0"/>
+          </a:p>
+          <a:p>
+            <a:pPr marL="342900" indent="-342900">
+              <a:spcAft>
+                <a:spcPts val="400"/>
+              </a:spcAft>
+              <a:buSzPct val="100000"/>
+              <a:buChar char="•"/>
+            </a:pPr>
+            <a:r>
+              <a:rPr lang="en-US" sz="1400" dirty="0">
+                <a:solidFill>
+                  <a:schemeClr val="tx1"/>
+                </a:solidFill>
+              </a:rPr>
+              <a:t>CastRole: characterName, billingOrder</a:t>
             </a:r>
             <a:endParaRPr lang="en-US" sz="1400" dirty="0"/>
           </a:p>
@@ -20805,7 +21115,7 @@
       </p:sp>
       <p:sp>
         <p:nvSpPr>
-          <p:cNvPr id="4" name="text-124"/>
+          <p:cNvPr id="4" name="text-129"/>
           <p:cNvSpPr txBox="1"/>
           <p:nvPr/>
         </p:nvSpPr>
@@ -20844,7 +21154,7 @@
       </p:sp>
       <p:sp>
         <p:nvSpPr>
-          <p:cNvPr id="5" name="text-125"/>
+          <p:cNvPr id="5" name="text-130"/>
           <p:cNvSpPr txBox="1"/>
           <p:nvPr/>
         </p:nvSpPr>
@@ -20880,7 +21190,7 @@
       </p:sp>
       <p:sp>
         <p:nvSpPr>
-          <p:cNvPr id="6" name="text-126"/>
+          <p:cNvPr id="6" name="text-131"/>
           <p:cNvSpPr txBox="1"/>
           <p:nvPr/>
         </p:nvSpPr>
@@ -20943,7 +21253,7 @@
       </p:sp>
       <p:sp>
         <p:nvSpPr>
-          <p:cNvPr id="8" name="text-127"/>
+          <p:cNvPr id="8" name="text-132"/>
           <p:cNvSpPr txBox="1"/>
           <p:nvPr/>
         </p:nvSpPr>
@@ -20982,7 +21292,7 @@
       </p:sp>
       <p:sp>
         <p:nvSpPr>
-          <p:cNvPr id="9" name="text-128"/>
+          <p:cNvPr id="9" name="text-133"/>
           <p:cNvSpPr txBox="1"/>
           <p:nvPr/>
         </p:nvSpPr>
@@ -21018,7 +21328,7 @@
       </p:sp>
       <p:sp>
         <p:nvSpPr>
-          <p:cNvPr id="10" name="text-129"/>
+          <p:cNvPr id="10" name="text-134"/>
           <p:cNvSpPr txBox="1"/>
           <p:nvPr/>
         </p:nvSpPr>
@@ -21081,7 +21391,7 @@
       </p:sp>
       <p:sp>
         <p:nvSpPr>
-          <p:cNvPr id="12" name="text-130"/>
+          <p:cNvPr id="12" name="text-135"/>
           <p:cNvSpPr txBox="1"/>
           <p:nvPr/>
         </p:nvSpPr>
@@ -21120,7 +21430,7 @@
       </p:sp>
       <p:sp>
         <p:nvSpPr>
-          <p:cNvPr id="13" name="text-131"/>
+          <p:cNvPr id="13" name="text-136"/>
           <p:cNvSpPr txBox="1"/>
           <p:nvPr/>
         </p:nvSpPr>
@@ -21156,7 +21466,7 @@
       </p:sp>
       <p:sp>
         <p:nvSpPr>
-          <p:cNvPr id="14" name="text-132"/>
+          <p:cNvPr id="14" name="text-137"/>
           <p:cNvSpPr txBox="1"/>
           <p:nvPr/>
         </p:nvSpPr>
@@ -21219,7 +21529,7 @@
       </p:sp>
       <p:sp>
         <p:nvSpPr>
-          <p:cNvPr id="16" name="text-133"/>
+          <p:cNvPr id="16" name="text-138"/>
           <p:cNvSpPr txBox="1"/>
           <p:nvPr/>
         </p:nvSpPr>
@@ -21258,7 +21568,7 @@
       </p:sp>
       <p:sp>
         <p:nvSpPr>
-          <p:cNvPr id="17" name="text-134"/>
+          <p:cNvPr id="17" name="text-139"/>
           <p:cNvSpPr txBox="1"/>
           <p:nvPr/>
         </p:nvSpPr>
@@ -21294,7 +21604,7 @@
       </p:sp>
       <p:sp>
         <p:nvSpPr>
-          <p:cNvPr id="18" name="text-135"/>
+          <p:cNvPr id="18" name="text-140"/>
           <p:cNvSpPr txBox="1"/>
           <p:nvPr/>
         </p:nvSpPr>
@@ -21330,7 +21640,7 @@
       </p:sp>
       <p:sp>
         <p:nvSpPr>
-          <p:cNvPr id="19" name="icon-bg-136"/>
+          <p:cNvPr id="19" name="icon-bg-141"/>
           <p:cNvSpPr/>
           <p:nvPr/>
         </p:nvSpPr>
@@ -21355,7 +21665,7 @@
       </p:sp>
       <p:pic>
         <p:nvPicPr>
-          <p:cNvPr id="20" name="icon-136" descr="preencoded.png">    </p:cNvPr>
+          <p:cNvPr id="20" name="icon-141" descr="preencoded.png">    </p:cNvPr>
           <p:cNvPicPr>
             <a:picLocks noChangeAspect="1"/>
           </p:cNvPicPr>
@@ -21379,7 +21689,7 @@
       </p:pic>
       <p:sp>
         <p:nvSpPr>
-          <p:cNvPr id="21" name="text-137"/>
+          <p:cNvPr id="21" name="text-142"/>
           <p:cNvSpPr txBox="1"/>
           <p:nvPr/>
         </p:nvSpPr>
@@ -21407,7 +21717,7 @@
                   <a:schemeClr val="tx1"/>
                 </a:solidFill>
               </a:rPr>
-              <a:t>Same counts in Protégé and in scripts/check_reasoning.py.  </a:t>
+              <a:t>Counts from HermiT, run by scripts/check_reasoning.py.  </a:t>
             </a:r>
             <a:pPr indent="0" marL="0">
               <a:buNone/>
@@ -21534,7 +21844,7 @@
       </p:sp>
       <p:sp>
         <p:nvSpPr>
-          <p:cNvPr id="3" name="text-138"/>
+          <p:cNvPr id="3" name="text-143"/>
           <p:cNvSpPr txBox="1"/>
           <p:nvPr/>
         </p:nvSpPr>
@@ -21570,7 +21880,7 @@
       </p:sp>
       <p:sp>
         <p:nvSpPr>
-          <p:cNvPr id="4" name="text-139"/>
+          <p:cNvPr id="4" name="text-144"/>
           <p:cNvSpPr txBox="1"/>
           <p:nvPr/>
         </p:nvSpPr>
@@ -21633,7 +21943,7 @@
       </p:sp>
       <p:sp>
         <p:nvSpPr>
-          <p:cNvPr id="6" name="text-140"/>
+          <p:cNvPr id="6" name="text-145"/>
           <p:cNvSpPr txBox="1"/>
           <p:nvPr/>
         </p:nvSpPr>
@@ -21706,7 +22016,7 @@
       </p:sp>
       <p:sp>
         <p:nvSpPr>
-          <p:cNvPr id="7" name="text-141"/>
+          <p:cNvPr id="7" name="text-146"/>
           <p:cNvSpPr txBox="1"/>
           <p:nvPr/>
         </p:nvSpPr>
@@ -21742,7 +22052,7 @@
       </p:sp>
       <p:sp>
         <p:nvSpPr>
-          <p:cNvPr id="8" name="text-142"/>
+          <p:cNvPr id="8" name="text-147"/>
           <p:cNvSpPr txBox="1"/>
           <p:nvPr/>
         </p:nvSpPr>
@@ -21805,7 +22115,7 @@
       </p:sp>
       <p:sp>
         <p:nvSpPr>
-          <p:cNvPr id="10" name="text-143"/>
+          <p:cNvPr id="10" name="text-148"/>
           <p:cNvSpPr txBox="1"/>
           <p:nvPr/>
         </p:nvSpPr>
@@ -21861,7 +22171,7 @@
       </p:sp>
       <p:sp>
         <p:nvSpPr>
-          <p:cNvPr id="11" name="text-144"/>
+          <p:cNvPr id="11" name="text-149"/>
           <p:cNvSpPr txBox="1"/>
           <p:nvPr/>
         </p:nvSpPr>
@@ -21897,7 +22207,7 @@
       </p:sp>
       <p:sp>
         <p:nvSpPr>
-          <p:cNvPr id="12" name="text-145"/>
+          <p:cNvPr id="12" name="text-150"/>
           <p:cNvSpPr txBox="1"/>
           <p:nvPr/>
         </p:nvSpPr>
@@ -21960,7 +22270,7 @@
       </p:sp>
       <p:sp>
         <p:nvSpPr>
-          <p:cNvPr id="14" name="text-146"/>
+          <p:cNvPr id="14" name="text-151"/>
           <p:cNvSpPr txBox="1"/>
           <p:nvPr/>
         </p:nvSpPr>
@@ -22151,7 +22461,7 @@
       </p:sp>
       <p:sp>
         <p:nvSpPr>
-          <p:cNvPr id="4" name="text-147"/>
+          <p:cNvPr id="4" name="text-152"/>
           <p:cNvSpPr txBox="1"/>
           <p:nvPr/>
         </p:nvSpPr>
@@ -22228,7 +22538,7 @@
       </p:sp>
       <p:sp>
         <p:nvSpPr>
-          <p:cNvPr id="6" name="text-148"/>
+          <p:cNvPr id="6" name="text-153"/>
           <p:cNvSpPr txBox="1"/>
           <p:nvPr/>
         </p:nvSpPr>
@@ -22305,7 +22615,7 @@
       </p:sp>
       <p:sp>
         <p:nvSpPr>
-          <p:cNvPr id="8" name="text-149"/>
+          <p:cNvPr id="8" name="text-154"/>
           <p:cNvSpPr txBox="1"/>
           <p:nvPr/>
         </p:nvSpPr>
@@ -22382,7 +22692,7 @@
       </p:sp>
       <p:sp>
         <p:nvSpPr>
-          <p:cNvPr id="10" name="text-150"/>
+          <p:cNvPr id="10" name="text-155"/>
           <p:cNvSpPr txBox="1"/>
           <p:nvPr/>
         </p:nvSpPr>
@@ -22432,7 +22742,7 @@
       </p:sp>
       <p:sp>
         <p:nvSpPr>
-          <p:cNvPr id="11" name="edge-151"/>
+          <p:cNvPr id="11" name="edge-156"/>
           <p:cNvSpPr/>
           <p:nvPr/>
         </p:nvSpPr>
@@ -22456,7 +22766,7 @@
       </p:sp>
       <p:sp>
         <p:nvSpPr>
-          <p:cNvPr id="12" name="edge-152"/>
+          <p:cNvPr id="12" name="edge-157"/>
           <p:cNvSpPr/>
           <p:nvPr/>
         </p:nvSpPr>
@@ -22480,7 +22790,7 @@
       </p:sp>
       <p:sp>
         <p:nvSpPr>
-          <p:cNvPr id="13" name="edge-153"/>
+          <p:cNvPr id="13" name="edge-158"/>
           <p:cNvSpPr/>
           <p:nvPr/>
         </p:nvSpPr>
@@ -22504,7 +22814,7 @@
       </p:sp>
       <p:sp>
         <p:nvSpPr>
-          <p:cNvPr id="14" name="edge-154"/>
+          <p:cNvPr id="14" name="edge-159"/>
           <p:cNvSpPr/>
           <p:nvPr/>
         </p:nvSpPr>
@@ -22555,7 +22865,7 @@
       </p:sp>
       <p:sp>
         <p:nvSpPr>
-          <p:cNvPr id="16" name="text-155"/>
+          <p:cNvPr id="16" name="text-160"/>
           <p:cNvSpPr txBox="1"/>
           <p:nvPr/>
         </p:nvSpPr>
@@ -22605,7 +22915,7 @@
       </p:sp>
       <p:sp>
         <p:nvSpPr>
-          <p:cNvPr id="17" name="icon-bg-156"/>
+          <p:cNvPr id="17" name="icon-bg-161"/>
           <p:cNvSpPr/>
           <p:nvPr/>
         </p:nvSpPr>
@@ -22630,7 +22940,7 @@
       </p:sp>
       <p:pic>
         <p:nvPicPr>
-          <p:cNvPr id="18" name="icon-156" descr="preencoded.png">    </p:cNvPr>
+          <p:cNvPr id="18" name="icon-161" descr="preencoded.png">    </p:cNvPr>
           <p:cNvPicPr>
             <a:picLocks noChangeAspect="1"/>
           </p:cNvPicPr>
@@ -22654,7 +22964,7 @@
       </p:pic>
       <p:sp>
         <p:nvSpPr>
-          <p:cNvPr id="19" name="text-157"/>
+          <p:cNvPr id="19" name="text-162"/>
           <p:cNvSpPr txBox="1"/>
           <p:nvPr/>
         </p:nvSpPr>

</xml_diff>

<commit_message>
docs: demo steps checked in Protégé, slide 7 credits the Protégé run
The demo was run in Protégé 5.6.9: HermiT takes about 3 minutes, DL Query needs prefixed names (ont:ActionMovie) and lists each individual three times because of owl:sameAs (ActionMovie 87 = 29 x 3, ComedyMovie 48, AwardWinningDirector 95, CastRole 750, ActorDirector 15 after the SWRL rule). make_protege_demo.py writes the two merged files the demo and video scripts need; DEMO_SCRIPT.md is rewritten with the checked steps and DEMO_VIDEO_SCRIPT.md gets the same fixes. Slide 7 now says the counts match in Protégé and check_reasoning.py; demo speaker notes remind to start the reasoner before the talk.
</commit_message>
<xml_diff>
--- a/slides/Group2_Capstone_Slides.pptx
+++ b/slides/Group2_Capstone_Slides.pptx
@@ -126,7 +126,7 @@
   <p:extLst>
     <p:ext uri="{521415D9-36F7-43E2-AB2F-B90AF26B5E84}">
       <p14:sectionLst xmlns:p14="http://schemas.microsoft.com/office/powerpoint/2010/main">
-        <p14:section name="Introduction" id="{8a125597-65d1-5ae3-d38c-dd0b973f7980}">
+        <p14:section name="Introduction" id="{74d343d9-51ee-b787-9b78-d7a220f21f06}">
           <p14:sldIdLst>
             <p14:sldId id="256"/>
             <p14:sldId id="257"/>
@@ -134,7 +134,7 @@
             <p14:sldId id="259"/>
           </p14:sldIdLst>
         </p14:section>
-        <p14:section name="Ontology and reasoning" id="{7c06a335-5252-7b87-a9a9-acd069352113}">
+        <p14:section name="Ontology and reasoning" id="{4f5164b0-d492-1640-2867-296db836d601}">
           <p14:sldIdLst>
             <p14:sldId id="260"/>
             <p14:sldId id="261"/>
@@ -143,7 +143,7 @@
             <p14:sldId id="264"/>
           </p14:sldIdLst>
         </p14:section>
-        <p14:section name="Data and linking" id="{36858b68-19b0-3d76-42ca-7375615db1f0}">
+        <p14:section name="Data and linking" id="{1f3626fb-5830-aa18-3909-67db29c67ef9}">
           <p14:sldIdLst>
             <p14:sldId id="265"/>
             <p14:sldId id="266"/>
@@ -153,14 +153,14 @@
             <p14:sldId id="270"/>
           </p14:sldIdLst>
         </p14:section>
-        <p14:section name="Querying and demo" id="{40784784-6862-0d82-98ab-67196873e818}">
+        <p14:section name="Querying and demo" id="{8b4a4edc-1260-8b0f-4642-a28c0ff7a847}">
           <p14:sldIdLst>
             <p14:sldId id="271"/>
             <p14:sldId id="272"/>
             <p14:sldId id="273"/>
           </p14:sldIdLst>
         </p14:section>
-        <p14:section name="Wrap-up" id="{5cdde5df-593e-a270-71ff-30da253f5dad}">
+        <p14:section name="Wrap-up" id="{2b44c677-2e58-4e16-f1ae-5874fbfd044a}">
           <p14:sldIdLst>
             <p14:sldId id="274"/>
             <p14:sldId id="275"/>
@@ -1694,9 +1694,9 @@
               <a:rPr lang="en-US" dirty="0"/>
               <a:t>Minh · ~3–4 min
 ENGLISH
-Now let me show it live. I'll open the ontology in Protégé and merge in the data and the awards. Then I'll start HermiT, so you can see the defined classes fill up. I'll run a couple of the sample queries, and one federated query from the terminal. After that I'll add the SWRL rule, and finally I'll break the ontology on purpose with the bad movie, so you can see the explanation. (Before the talk: run the federated queries once to check that the endpoints are up, and remove the bad movie file after the demo.)
+Now let me show it live. I'll open the ontology in Protégé and merge in the data and the awards. Then I'll start HermiT, so you can see the defined classes fill up. I'll run a couple of the sample queries, and one federated query from the terminal. After that I'll add the SWRL rule, and finally I'll break the ontology on purpose with the bad movie, so you can see the explanation. (Before the talk: start HermiT and add the SWRL rule in advance — the reasoner takes three to four minutes in Protégé. Run the federated queries once to check that the endpoints are up. In the DL Query tab, type ont:ActionMovie, press Esc, then Execute; each film is listed three times because of owl:sameAs.)
 TIẾNG VIỆT
-Giờ em xin demo trực tiếp. Em sẽ mở ontology trong Protégé và gộp dữ liệu cùng giải thưởng vào. Sau đó em chạy HermiT để mọi người thấy các defined class tự có thành viên. Em sẽ chạy vài truy vấn mẫu, và một truy vấn federated trên terminal. Tiếp theo em thêm luật SWRL, và cuối cùng em cố tình làm hỏng ontology bằng bộ phim lỗi để mọi người xem phần giải thích. (Trước giờ trình bày: chạy thử các truy vấn federated một lần để chắc endpoint đang hoạt động, và gỡ file phim lỗi sau khi demo xong.)</a:t>
+Giờ em xin demo trực tiếp. Em sẽ mở ontology trong Protégé và gộp dữ liệu cùng giải thưởng vào. Sau đó em chạy HermiT để mọi người thấy các defined class tự có thành viên. Em sẽ chạy vài truy vấn mẫu, và một truy vấn federated trên terminal. Tiếp theo em thêm luật SWRL, và cuối cùng em cố tình làm hỏng ontology bằng bộ phim lỗi để mọi người xem phần giải thích. (Trước giờ trình bày: chạy HermiT và thêm luật SWRL từ trước — reasoner trong Protégé mất ba đến bốn phút. Chạy thử các truy vấn federated một lần để chắc endpoint đang hoạt động. Trong tab DL Query, gõ ont:ActionMovie, bấm Esc rồi Execute; mỗi phim hiện ba lần do owl:sameAs.)</a:t>
             </a:r>
             <a:endParaRPr lang="en-US" dirty="0"/>
           </a:p>
@@ -2430,9 +2430,9 @@
               <a:rPr lang="en-US" dirty="0"/>
               <a:t>Minh · ~45 s
 ENGLISH
-This is the part we like most. Nobody in our data is tagged as an action movie or as an award-winning director. But once we run HermiT, the reasoner works it out by itself: 29 action movies, 16 comedies, 32 award-winning directors, and 5 people who directed and acted in the same film — Clint Eastwood is one of them. These counts come from running HermiT in our check_reasoning script, and in the demo you'll see the same reasoner at work in Protégé.
+This is the part we like most. Nobody in our data is tagged as an action movie or as an award-winning director. But once we run HermiT, the reasoner works it out by itself: 29 action movies, 16 comedies, 32 award-winning directors, and 5 people who directed and acted in the same film — Clint Eastwood is one of them. We get exactly the same numbers in Protégé and from our check_reasoning script — both use HermiT.
 TIẾNG VIỆT
-Đây là phần nhóm thích nhất. Trong dữ liệu không có phim nào được gắn nhãn là phim hành động, cũng không có ai được gắn là đạo diễn đoạt giải. Nhưng khi chạy HermiT, reasoner tự suy ra: 29 phim hành động, 16 phim hài, 32 đạo diễn từng đoạt giải, và 5 người vừa đạo diễn vừa đóng trong cùng một phim — Clint Eastwood là một ví dụ. Các con số này có được khi chạy HermiT bằng script check_reasoning, và trong phần demo mọi người sẽ thấy cùng reasoner đó chạy trong Protégé.</a:t>
+Đây là phần nhóm thích nhất. Trong dữ liệu không có phim nào được gắn nhãn là phim hành động, cũng không có ai được gắn là đạo diễn đoạt giải. Nhưng khi chạy HermiT, reasoner tự suy ra: 29 phim hành động, 16 phim hài, 32 đạo diễn từng đoạt giải, và 5 người vừa đạo diễn vừa đóng trong cùng một phim — Clint Eastwood là một ví dụ. Số liệu trong Protégé và trong script check_reasoning trùng khớp hoàn toàn — cả hai đều dùng HermiT.</a:t>
             </a:r>
             <a:endParaRPr lang="en-US" dirty="0"/>
           </a:p>
@@ -21717,7 +21717,7 @@
                   <a:schemeClr val="tx1"/>
                 </a:solidFill>
               </a:rPr>
-              <a:t>Counts from HermiT, run by scripts/check_reasoning.py.  </a:t>
+              <a:t>Same counts in Protégé and in scripts/check_reasoning.py, both with HermiT.  </a:t>
             </a:r>
             <a:pPr indent="0" marL="0">
               <a:buNone/>

</xml_diff>

<commit_message>
docs: use the Snap SPARQL plugin for SPARQL inside Protégé
The SPARQL Query plugin bundled with Protégé 5.6.9 does not load (NoClassDefFoundError: com/google/common/base/Optional). Snap SPARQL Query 6.0.0, installed from Protégé's plugin list, works and answers through the reasoner: instances of ont:ActionMovie return 87 rows, the same as the DL query. README explains the install; the report and the slides (interfaces box, demo step 3, speaker notes) now name Snap SPARQL instead of the built-in tab.
</commit_message>
<xml_diff>
--- a/slides/Group2_Capstone_Slides.pptx
+++ b/slides/Group2_Capstone_Slides.pptx
@@ -121,13 +121,13 @@
   <p:extLst>
     <p:ext uri="{521415D9-36F7-43E2-AB2F-B90AF26B5E84}">
       <p14:sectionLst xmlns:p14="http://schemas.microsoft.com/office/powerpoint/2010/main">
-        <p14:section name="Introduction" id="{ef7dcbdc-0627-e0aa-0775-39152bf5a3ec}">
+        <p14:section name="Introduction" id="{f4cf2826-7d7b-e767-5d29-9e7577bb7d72}">
           <p14:sldIdLst>
             <p14:sldId id="256"/>
             <p14:sldId id="257"/>
           </p14:sldIdLst>
         </p14:section>
-        <p14:section name="Ontology and reasoning" id="{6cf2837d-c747-7f28-b7c7-4acc84ee97c1}">
+        <p14:section name="Ontology and reasoning" id="{4c6a92aa-6d7c-0135-e2af-20314ccb548e}">
           <p14:sldIdLst>
             <p14:sldId id="258"/>
             <p14:sldId id="259"/>
@@ -135,7 +135,7 @@
             <p14:sldId id="261"/>
           </p14:sldIdLst>
         </p14:section>
-        <p14:section name="Data and linking" id="{09d6f0d7-83b5-a5fd-321e-94c2ae80f96c}">
+        <p14:section name="Data and linking" id="{fa89027f-624c-a373-6045-4fb8def77ade}">
           <p14:sldIdLst>
             <p14:sldId id="262"/>
             <p14:sldId id="263"/>
@@ -143,14 +143,14 @@
             <p14:sldId id="265"/>
           </p14:sldIdLst>
         </p14:section>
-        <p14:section name="Querying and demo" id="{1f78d635-203b-b996-546c-a20630d832ac}">
+        <p14:section name="Querying and demo" id="{64bcbe51-b122-9cd5-0ddc-c23ad6762d73}">
           <p14:sldIdLst>
             <p14:sldId id="266"/>
             <p14:sldId id="267"/>
             <p14:sldId id="268"/>
           </p14:sldIdLst>
         </p14:section>
-        <p14:section name="Wrap-up" id="{7e7bee8d-d5de-7c32-bb41-517a59cf48be}">
+        <p14:section name="Wrap-up" id="{c08ff0ce-a662-ae5d-15fc-cc11c2e22185}">
           <p14:sldIdLst>
             <p14:sldId id="269"/>
             <p14:sldId id="270"/>
@@ -1040,9 +1040,9 @@
               <a:rPr lang="en-US" dirty="0"/>
               <a:t>Minh · ~40 s
 ENGLISH
-Thanks, Đức. You can query the graph in two ways: from the terminal with our sparql_cli script, or in Protégé's SPARQL tab. Here's query three, which answers 'which director has the most movies'. Steven Spielberg comes first with eight, followed by Tarantino and Nolan with seven each. Altogether there are 21 queries: five local ones — one per competency question, plus a check on the links — six on cast roles, and ten federated queries. Chiến wrote the cast-role and federated ones.
+Thanks, Đức. You can query the graph in two ways: from the terminal with our sparql_cli script, or inside Protégé with the Snap SPARQL plugin, which also sees what the reasoner inferred. Here's query three, which answers 'which director has the most movies'. Steven Spielberg comes first with eight, followed by Tarantino and Nolan with seven each. Altogether there are 21 queries: five local ones — one per competency question, plus a check on the links — six on cast roles, and ten federated queries. Chiến wrote the cast-role and federated ones.
 TIẾNG VIỆT
-Cảm ơn Đức. Có hai cách truy vấn đồ thị: chạy trên terminal bằng script sparql_cli, hoặc dùng tab SPARQL trong Protégé. Đây là truy vấn số ba, trả lời câu hỏi đạo diễn nào có nhiều phim nhất. Steven Spielberg đứng đầu với tám phim, sau đó là Tarantino và Nolan, mỗi người bảy phim. Tổng cộng có 21 truy vấn: năm truy vấn local — mỗi câu ứng với một competency question, thêm một câu kiểm tra liên kết — sáu truy vấn về vai diễn, và mười truy vấn federated. Phần vai diễn và federated do Chiến viết.</a:t>
+Cảm ơn Đức. Có hai cách truy vấn đồ thị: chạy trên terminal bằng script sparql_cli, hoặc ngay trong Protégé bằng plugin Snap SPARQL, plugin này còn thấy được cả kết quả suy luận của reasoner. Đây là truy vấn số ba, trả lời câu hỏi đạo diễn nào có nhiều phim nhất. Steven Spielberg đứng đầu với tám phim, sau đó là Tarantino và Nolan, mỗi người bảy phim. Tổng cộng có 21 truy vấn: năm truy vấn local — mỗi câu ứng với một competency question, thêm một câu kiểm tra liên kết — sáu truy vấn về vai diễn, và mười truy vấn federated. Phần vai diễn và federated do Chiến viết.</a:t>
             </a:r>
             <a:endParaRPr lang="en-US" dirty="0"/>
           </a:p>
@@ -1224,9 +1224,9 @@
               <a:rPr lang="en-US" dirty="0"/>
               <a:t>Minh · ~3–4 min
 ENGLISH
-Now let me show it live. I'll open the ontology in Protégé and merge in the data and the awards. Then I'll start HermiT, so you can see the defined classes fill up. I'll run a couple of the sample queries, and one federated query from the terminal. After that I'll add the SWRL rule, and finally I'll break the ontology on purpose with the bad movie, so you can see the explanation. (Before the talk: start HermiT and add the SWRL rule in advance — the reasoner takes three to four minutes in Protégé. Run the federated queries once to check that the endpoints are up. In the DL Query tab, type ont:ActionMovie, press Esc, then Execute; each film is listed three times because of owl:sameAs.)
+Now let me show it live. I'll open the ontology in Protégé and merge in the data and the awards. Then I'll start HermiT, so you can see the defined classes fill up. I'll ask the same question in SPARQL with the Snap SPARQL plugin, which goes through the reasoner, and run one federated query from the terminal. After that I'll add the SWRL rule, and finally I'll break the ontology on purpose with the bad movie, so you can see the explanation. (Before the talk: start HermiT and add the SWRL rule in advance — the reasoner takes three to four minutes in Protégé. Run the federated queries once to check that the endpoints are up. In the DL Query tab, type ont:ActionMovie, press Esc, then Execute; each film is listed three times because of owl:sameAs.)
 TIẾNG VIỆT
-Giờ em xin demo trực tiếp. Em sẽ mở ontology trong Protégé và gộp dữ liệu cùng giải thưởng vào. Sau đó em chạy HermiT để mọi người thấy các defined class tự có thành viên. Em sẽ chạy vài truy vấn mẫu, và một truy vấn federated trên terminal. Tiếp theo em thêm luật SWRL, và cuối cùng em cố tình làm hỏng ontology bằng bộ phim lỗi để mọi người xem phần giải thích. (Trước giờ trình bày: chạy HermiT và thêm luật SWRL từ trước — reasoner trong Protégé mất ba đến bốn phút. Chạy thử các truy vấn federated một lần để chắc endpoint đang hoạt động. Trong tab DL Query, gõ ont:ActionMovie, bấm Esc rồi Execute; mỗi phim hiện ba lần do owl:sameAs.)</a:t>
+Giờ em xin demo trực tiếp. Em sẽ mở ontology trong Protégé và gộp dữ liệu cùng giải thưởng vào. Sau đó em chạy HermiT để mọi người thấy các defined class tự có thành viên. Em sẽ hỏi lại câu đó bằng SPARQL qua plugin Snap SPARQL, plugin này truy vấn qua reasoner, và chạy một truy vấn federated trên terminal. Tiếp theo em thêm luật SWRL, và cuối cùng em cố tình làm hỏng ontology bằng bộ phim lỗi để mọi người xem phần giải thích. (Trước giờ trình bày: chạy HermiT và thêm luật SWRL từ trước — reasoner trong Protégé mất ba đến bốn phút. Chạy thử các truy vấn federated một lần để chắc endpoint đang hoạt động. Trong tab DL Query, gõ ont:ActionMovie, bấm Esc rồi Execute; mỗi phim hiện ba lần do owl:sameAs.)</a:t>
             </a:r>
             <a:endParaRPr lang="en-US" dirty="0"/>
           </a:p>
@@ -5346,7 +5346,7 @@
                   <a:schemeClr val="accent4"/>
                 </a:solidFill>
               </a:rPr>
-              <a:t>sparql_cli.py in a terminal, and Protégé's SPARQL tab</a:t>
+              <a:t>sparql_cli.py in a terminal, and Snap SPARQL in Protégé</a:t>
             </a:r>
             <a:endParaRPr lang="en-US" sz="1300" dirty="0"/>
           </a:p>
@@ -7998,7 +7998,7 @@
                   <a:schemeClr val="accent4"/>
                 </a:solidFill>
               </a:rPr>
-              <a:t>Run the sample queries in the SPARQL tab</a:t>
+              <a:t>Snap SPARQL in Protégé: instances of ActionMovie, 87 rows</a:t>
             </a:r>
             <a:endParaRPr lang="en-US" sz="1400" dirty="0"/>
           </a:p>

</xml_diff>